<commit_message>
Add scheduled analysis to the project deck
- New slide 6: schedule, analyze, store, email, review flow; daily,
  weekly and monthly cadences; scheduler safety rules
- Slide 2: scheduler uses the same service layer
- Slide 8: CLI schedule command, Mailpit, 99% coverage, 149 UI tests
- Slide 10: readiness checks on a schedule

Co-Authored-By: Claude Opus 5.5 <noreply@anthropic.com>
</commit_message>
<xml_diff>
--- a/docs/DR_Readiness_Agent.pptx
+++ b/docs/DR_Readiness_Agent.pptx
@@ -10,6 +10,7 @@
     <p:sldId id="258" r:id="rId4"/>
     <p:sldId id="259" r:id="rId5"/>
     <p:sldId id="260" r:id="rId6"/>
+    <p:sldId id="265" r:id="rId16"/>
     <p:sldId id="261" r:id="rId7"/>
     <p:sldId id="262" r:id="rId8"/>
     <p:sldId id="264" r:id="rId15"/>
@@ -2306,6 +2307,1343 @@
 </p:sld>
 </file>
 
+<file path=ppt/slides/slide10.xml><?xml version="1.0" encoding="utf-8"?>
+<p:sld xmlns:a="http://schemas.openxmlformats.org/drawingml/2006/main" xmlns:r="http://schemas.openxmlformats.org/officeDocument/2006/relationships" xmlns:p="http://schemas.openxmlformats.org/presentationml/2006/main">
+  <p:cSld name="Slide 4">
+    <p:bg>
+      <p:bgPr>
+        <a:solidFill>
+          <a:srgbClr val="0E1726"/>
+        </a:solidFill>
+      </p:bgPr>
+    </p:bg>
+    <p:spTree>
+      <p:nvGrpSpPr>
+        <p:cNvPr id="1" name=""/>
+        <p:cNvGrpSpPr/>
+        <p:nvPr/>
+      </p:nvGrpSpPr>
+      <p:grpSpPr>
+        <a:xfrm>
+          <a:off x="0" y="0"/>
+          <a:ext cx="0" cy="0"/>
+          <a:chOff x="0" y="0"/>
+          <a:chExt cx="0" cy="0"/>
+        </a:xfrm>
+      </p:grpSpPr>
+      <p:sp>
+        <p:nvSpPr>
+          <p:cNvPr id="2" name="Text 0"/>
+          <p:cNvSpPr txBox="1"/>
+          <p:nvPr/>
+        </p:nvSpPr>
+        <p:spPr>
+          <a:xfrm>
+            <a:off x="457200" y="274320"/>
+            <a:ext cx="8229600" cy="274320"/>
+          </a:xfrm>
+          <a:prstGeom prst="rect">
+            <a:avLst/>
+          </a:prstGeom>
+          <a:noFill/>
+          <a:ln/>
+        </p:spPr>
+        <p:txBody>
+          <a:bodyPr wrap="square" lIns="0" tIns="0" rIns="0" bIns="0" rtlCol="0" anchor="ctr"/>
+          <a:lstStyle/>
+          <a:p>
+            <a:pPr indent="0" marL="0">
+              <a:buNone/>
+            </a:pPr>
+            <a:r>
+              <a:rPr lang="en-US" sz="1100" b="1" spc="300" kern="0" dirty="0">
+                <a:solidFill>
+                  <a:srgbClr val="F5A524"/>
+                </a:solidFill>
+                <a:latin typeface="Arial" pitchFamily="34" charset="0"/>
+                <a:ea typeface="Arial" pitchFamily="34" charset="-122"/>
+                <a:cs typeface="Arial" pitchFamily="34" charset="-120"/>
+              </a:rPr>
+              <a:t>SCHEDULED ANALYSIS</a:t>
+            </a:r>
+            <a:endParaRPr lang="en-US" sz="1100" dirty="0"/>
+          </a:p>
+        </p:txBody>
+      </p:sp>
+      <p:sp>
+        <p:nvSpPr>
+          <p:cNvPr id="3" name="Text 1"/>
+          <p:cNvSpPr txBox="1"/>
+          <p:nvPr/>
+        </p:nvSpPr>
+        <p:spPr>
+          <a:xfrm>
+            <a:off x="457200" y="530352"/>
+            <a:ext cx="8229600" cy="548640"/>
+          </a:xfrm>
+          <a:prstGeom prst="rect">
+            <a:avLst/>
+          </a:prstGeom>
+          <a:noFill/>
+          <a:ln/>
+        </p:spPr>
+        <p:txBody>
+          <a:bodyPr wrap="square" lIns="0" tIns="0" rIns="0" bIns="0" rtlCol="0" anchor="ctr"/>
+          <a:lstStyle/>
+          <a:p>
+            <a:pPr indent="0" marL="0">
+              <a:buNone/>
+            </a:pPr>
+            <a:r>
+              <a:rPr lang="en-US" sz="2800" b="1" dirty="0">
+                <a:solidFill>
+                  <a:srgbClr val="FFFFFF"/>
+                </a:solidFill>
+                <a:latin typeface="Arial" pitchFamily="34" charset="0"/>
+                <a:ea typeface="Arial" pitchFamily="34" charset="-122"/>
+                <a:cs typeface="Arial" pitchFamily="34" charset="-120"/>
+              </a:rPr>
+              <a:t>Scheduled checks, facts emailed to owners</a:t>
+            </a:r>
+            <a:endParaRPr lang="en-US" sz="2800" dirty="0"/>
+          </a:p>
+        </p:txBody>
+      </p:sp>
+      <p:sp>
+        <p:nvSpPr>
+          <p:cNvPr id="4" name="Shape 2"/>
+          <p:cNvSpPr/>
+          <p:nvPr/>
+        </p:nvSpPr>
+        <p:spPr>
+          <a:xfrm>
+            <a:off x="868680" y="1371600"/>
+            <a:ext cx="640080" cy="640080"/>
+          </a:xfrm>
+          <a:prstGeom prst="roundRect">
+            <a:avLst>
+              <a:gd name="adj" fmla="val 17143"/>
+            </a:avLst>
+          </a:prstGeom>
+          <a:solidFill>
+            <a:srgbClr val="334155"/>
+          </a:solidFill>
+          <a:ln w="12700">
+            <a:solidFill>
+              <a:srgbClr val="334155"/>
+            </a:solidFill>
+            <a:prstDash val="solid"/>
+          </a:ln>
+        </p:spPr>
+      </p:sp>
+      <p:pic>
+        <p:nvPicPr>
+          <p:cNvPr id="5" name="Image 0" descr="calendar icon">    </p:cNvPr>
+          <p:cNvPicPr>
+            <a:picLocks noChangeAspect="1"/>
+          </p:cNvPicPr>
+          <p:nvPr/>
+        </p:nvPicPr>
+        <p:blipFill>
+          <a:blip r:embed="rId1"/>
+          <a:stretch>
+            <a:fillRect/>
+          </a:stretch>
+        </p:blipFill>
+        <p:spPr>
+          <a:xfrm>
+            <a:off x="1035101" y="1538021"/>
+            <a:ext cx="307238" cy="307238"/>
+          </a:xfrm>
+          <a:prstGeom prst="rect">
+            <a:avLst/>
+          </a:prstGeom>
+        </p:spPr>
+      </p:pic>
+      <p:sp>
+        <p:nvSpPr>
+          <p:cNvPr id="6" name="Text 3"/>
+          <p:cNvSpPr txBox="1"/>
+          <p:nvPr/>
+        </p:nvSpPr>
+        <p:spPr>
+          <a:xfrm>
+            <a:off x="457200" y="2103120"/>
+            <a:ext cx="1463040" cy="320040"/>
+          </a:xfrm>
+          <a:prstGeom prst="rect">
+            <a:avLst/>
+          </a:prstGeom>
+          <a:noFill/>
+          <a:ln/>
+        </p:spPr>
+        <p:txBody>
+          <a:bodyPr wrap="square" lIns="0" tIns="0" rIns="0" bIns="0" rtlCol="0" anchor="ctr"/>
+          <a:lstStyle/>
+          <a:p>
+            <a:pPr algn="ctr" indent="0" marL="0">
+              <a:buNone/>
+            </a:pPr>
+            <a:r>
+              <a:rPr lang="en-US" sz="1500" b="1" dirty="0">
+                <a:solidFill>
+                  <a:srgbClr val="FFFFFF"/>
+                </a:solidFill>
+                <a:latin typeface="Arial" pitchFamily="34" charset="0"/>
+                <a:ea typeface="Arial" pitchFamily="34" charset="-122"/>
+                <a:cs typeface="Arial" pitchFamily="34" charset="-120"/>
+              </a:rPr>
+              <a:t>Schedule</a:t>
+            </a:r>
+            <a:endParaRPr lang="en-US" sz="1500" dirty="0"/>
+          </a:p>
+        </p:txBody>
+      </p:sp>
+      <p:sp>
+        <p:nvSpPr>
+          <p:cNvPr id="7" name="Text 4"/>
+          <p:cNvSpPr txBox="1"/>
+          <p:nvPr/>
+        </p:nvSpPr>
+        <p:spPr>
+          <a:xfrm>
+            <a:off x="457200" y="2450592"/>
+            <a:ext cx="1463040" cy="685800"/>
+          </a:xfrm>
+          <a:prstGeom prst="rect">
+            <a:avLst/>
+          </a:prstGeom>
+          <a:noFill/>
+          <a:ln/>
+        </p:spPr>
+        <p:txBody>
+          <a:bodyPr wrap="square" lIns="0" tIns="0" rIns="0" bIns="0" rtlCol="0" anchor="t"/>
+          <a:lstStyle/>
+          <a:p>
+            <a:pPr algn="ctr" indent="0" marL="0">
+              <a:buNone/>
+            </a:pPr>
+            <a:r>
+              <a:rPr lang="en-US" sz="1100" dirty="0">
+                <a:solidFill>
+                  <a:srgbClr val="CBD5E1"/>
+                </a:solidFill>
+                <a:latin typeface="Calibri" pitchFamily="34" charset="0"/>
+                <a:ea typeface="Calibri" pitchFamily="34" charset="-122"/>
+                <a:cs typeface="Calibri" pitchFamily="34" charset="-120"/>
+              </a:rPr>
+              <a:t>Daily, weekly or monthly, at a set time in your timezone</a:t>
+            </a:r>
+            <a:endParaRPr lang="en-US" sz="1100" dirty="0"/>
+          </a:p>
+        </p:txBody>
+      </p:sp>
+      <p:sp>
+        <p:nvSpPr>
+          <p:cNvPr id="8" name="Shape 5"/>
+          <p:cNvSpPr/>
+          <p:nvPr/>
+        </p:nvSpPr>
+        <p:spPr>
+          <a:xfrm>
+            <a:off x="1645920" y="1691640"/>
+            <a:ext cx="640080" cy="0"/>
+          </a:xfrm>
+          <a:prstGeom prst="line">
+            <a:avLst/>
+          </a:prstGeom>
+          <a:noFill/>
+          <a:ln w="19050">
+            <a:solidFill>
+              <a:srgbClr val="475569"/>
+            </a:solidFill>
+            <a:prstDash val="solid"/>
+            <a:tailEnd type="triangle"/>
+          </a:ln>
+        </p:spPr>
+      </p:sp>
+      <p:sp>
+        <p:nvSpPr>
+          <p:cNvPr id="9" name="Shape 6"/>
+          <p:cNvSpPr/>
+          <p:nvPr/>
+        </p:nvSpPr>
+        <p:spPr>
+          <a:xfrm>
+            <a:off x="2551176" y="1371600"/>
+            <a:ext cx="640080" cy="640080"/>
+          </a:xfrm>
+          <a:prstGeom prst="roundRect">
+            <a:avLst>
+              <a:gd name="adj" fmla="val 17143"/>
+            </a:avLst>
+          </a:prstGeom>
+          <a:solidFill>
+            <a:srgbClr val="F5A524"/>
+          </a:solidFill>
+          <a:ln w="12700">
+            <a:solidFill>
+              <a:srgbClr val="F5A524"/>
+            </a:solidFill>
+            <a:prstDash val="solid"/>
+          </a:ln>
+        </p:spPr>
+      </p:sp>
+      <p:pic>
+        <p:nvPicPr>
+          <p:cNvPr id="10" name="Image 1" descr="analyze icon">    </p:cNvPr>
+          <p:cNvPicPr>
+            <a:picLocks noChangeAspect="1"/>
+          </p:cNvPicPr>
+          <p:nvPr/>
+        </p:nvPicPr>
+        <p:blipFill>
+          <a:blip r:embed="rId2"/>
+          <a:stretch>
+            <a:fillRect/>
+          </a:stretch>
+        </p:blipFill>
+        <p:spPr>
+          <a:xfrm>
+            <a:off x="2717597" y="1538021"/>
+            <a:ext cx="307238" cy="307238"/>
+          </a:xfrm>
+          <a:prstGeom prst="rect">
+            <a:avLst/>
+          </a:prstGeom>
+        </p:spPr>
+      </p:pic>
+      <p:sp>
+        <p:nvSpPr>
+          <p:cNvPr id="11" name="Text 7"/>
+          <p:cNvSpPr txBox="1"/>
+          <p:nvPr/>
+        </p:nvSpPr>
+        <p:spPr>
+          <a:xfrm>
+            <a:off x="2139696" y="2103120"/>
+            <a:ext cx="1463040" cy="320040"/>
+          </a:xfrm>
+          <a:prstGeom prst="rect">
+            <a:avLst/>
+          </a:prstGeom>
+          <a:noFill/>
+          <a:ln/>
+        </p:spPr>
+        <p:txBody>
+          <a:bodyPr wrap="square" lIns="0" tIns="0" rIns="0" bIns="0" rtlCol="0" anchor="ctr"/>
+          <a:lstStyle/>
+          <a:p>
+            <a:pPr algn="ctr" indent="0" marL="0">
+              <a:buNone/>
+            </a:pPr>
+            <a:r>
+              <a:rPr lang="en-US" sz="1500" b="1" dirty="0">
+                <a:solidFill>
+                  <a:srgbClr val="FFFFFF"/>
+                </a:solidFill>
+                <a:latin typeface="Arial" pitchFamily="34" charset="0"/>
+                <a:ea typeface="Arial" pitchFamily="34" charset="-122"/>
+                <a:cs typeface="Arial" pitchFamily="34" charset="-120"/>
+              </a:rPr>
+              <a:t>Analyze</a:t>
+            </a:r>
+            <a:endParaRPr lang="en-US" sz="1500" dirty="0"/>
+          </a:p>
+        </p:txBody>
+      </p:sp>
+      <p:sp>
+        <p:nvSpPr>
+          <p:cNvPr id="12" name="Text 8"/>
+          <p:cNvSpPr txBox="1"/>
+          <p:nvPr/>
+        </p:nvSpPr>
+        <p:spPr>
+          <a:xfrm>
+            <a:off x="2139696" y="2450592"/>
+            <a:ext cx="1463040" cy="685800"/>
+          </a:xfrm>
+          <a:prstGeom prst="rect">
+            <a:avLst/>
+          </a:prstGeom>
+          <a:noFill/>
+          <a:ln/>
+        </p:spPr>
+        <p:txBody>
+          <a:bodyPr wrap="square" lIns="0" tIns="0" rIns="0" bIns="0" rtlCol="0" anchor="t"/>
+          <a:lstStyle/>
+          <a:p>
+            <a:pPr algn="ctr" indent="0" marL="0">
+              <a:buNone/>
+            </a:pPr>
+            <a:r>
+              <a:rPr lang="en-US" sz="1100" dirty="0">
+                <a:solidFill>
+                  <a:srgbClr val="CBD5E1"/>
+                </a:solidFill>
+                <a:latin typeface="Calibri" pitchFamily="34" charset="0"/>
+                <a:ea typeface="Calibri" pitchFamily="34" charset="-122"/>
+                <a:cs typeface="Calibri" pitchFamily="34" charset="-120"/>
+              </a:rPr>
+              <a:t>Same engine as a manual run, rules only if the LLM is down</a:t>
+            </a:r>
+            <a:endParaRPr lang="en-US" sz="1100" dirty="0"/>
+          </a:p>
+        </p:txBody>
+      </p:sp>
+      <p:sp>
+        <p:nvSpPr>
+          <p:cNvPr id="13" name="Shape 9"/>
+          <p:cNvSpPr/>
+          <p:nvPr/>
+        </p:nvSpPr>
+        <p:spPr>
+          <a:xfrm>
+            <a:off x="3328416" y="1691640"/>
+            <a:ext cx="640080" cy="0"/>
+          </a:xfrm>
+          <a:prstGeom prst="line">
+            <a:avLst/>
+          </a:prstGeom>
+          <a:noFill/>
+          <a:ln w="19050">
+            <a:solidFill>
+              <a:srgbClr val="475569"/>
+            </a:solidFill>
+            <a:prstDash val="solid"/>
+            <a:tailEnd type="triangle"/>
+          </a:ln>
+        </p:spPr>
+      </p:sp>
+      <p:sp>
+        <p:nvSpPr>
+          <p:cNvPr id="14" name="Shape 10"/>
+          <p:cNvSpPr/>
+          <p:nvPr/>
+        </p:nvSpPr>
+        <p:spPr>
+          <a:xfrm>
+            <a:off x="4233672" y="1371600"/>
+            <a:ext cx="640080" cy="640080"/>
+          </a:xfrm>
+          <a:prstGeom prst="roundRect">
+            <a:avLst>
+              <a:gd name="adj" fmla="val 17143"/>
+            </a:avLst>
+          </a:prstGeom>
+          <a:solidFill>
+            <a:srgbClr val="14B8A6"/>
+          </a:solidFill>
+          <a:ln w="12700">
+            <a:solidFill>
+              <a:srgbClr val="14B8A6"/>
+            </a:solidFill>
+            <a:prstDash val="solid"/>
+          </a:ln>
+        </p:spPr>
+      </p:sp>
+      <p:pic>
+        <p:nvPicPr>
+          <p:cNvPr id="15" name="Image 2" descr="history icon">    </p:cNvPr>
+          <p:cNvPicPr>
+            <a:picLocks noChangeAspect="1"/>
+          </p:cNvPicPr>
+          <p:nvPr/>
+        </p:nvPicPr>
+        <p:blipFill>
+          <a:blip r:embed="rId3"/>
+          <a:stretch>
+            <a:fillRect/>
+          </a:stretch>
+        </p:blipFill>
+        <p:spPr>
+          <a:xfrm>
+            <a:off x="4400093" y="1538021"/>
+            <a:ext cx="307238" cy="307238"/>
+          </a:xfrm>
+          <a:prstGeom prst="rect">
+            <a:avLst/>
+          </a:prstGeom>
+        </p:spPr>
+      </p:pic>
+      <p:sp>
+        <p:nvSpPr>
+          <p:cNvPr id="16" name="Text 11"/>
+          <p:cNvSpPr txBox="1"/>
+          <p:nvPr/>
+        </p:nvSpPr>
+        <p:spPr>
+          <a:xfrm>
+            <a:off x="3822192" y="2103120"/>
+            <a:ext cx="1463040" cy="320040"/>
+          </a:xfrm>
+          <a:prstGeom prst="rect">
+            <a:avLst/>
+          </a:prstGeom>
+          <a:noFill/>
+          <a:ln/>
+        </p:spPr>
+        <p:txBody>
+          <a:bodyPr wrap="square" lIns="0" tIns="0" rIns="0" bIns="0" rtlCol="0" anchor="ctr"/>
+          <a:lstStyle/>
+          <a:p>
+            <a:pPr algn="ctr" indent="0" marL="0">
+              <a:buNone/>
+            </a:pPr>
+            <a:r>
+              <a:rPr lang="en-US" sz="1500" b="1" dirty="0">
+                <a:solidFill>
+                  <a:srgbClr val="FFFFFF"/>
+                </a:solidFill>
+                <a:latin typeface="Arial" pitchFamily="34" charset="0"/>
+                <a:ea typeface="Arial" pitchFamily="34" charset="-122"/>
+                <a:cs typeface="Arial" pitchFamily="34" charset="-120"/>
+              </a:rPr>
+              <a:t>Store</a:t>
+            </a:r>
+            <a:endParaRPr lang="en-US" sz="1500" dirty="0"/>
+          </a:p>
+        </p:txBody>
+      </p:sp>
+      <p:sp>
+        <p:nvSpPr>
+          <p:cNvPr id="17" name="Text 12"/>
+          <p:cNvSpPr txBox="1"/>
+          <p:nvPr/>
+        </p:nvSpPr>
+        <p:spPr>
+          <a:xfrm>
+            <a:off x="3822192" y="2450592"/>
+            <a:ext cx="1463040" cy="685800"/>
+          </a:xfrm>
+          <a:prstGeom prst="rect">
+            <a:avLst/>
+          </a:prstGeom>
+          <a:noFill/>
+          <a:ln/>
+        </p:spPr>
+        <p:txBody>
+          <a:bodyPr wrap="square" lIns="0" tIns="0" rIns="0" bIns="0" rtlCol="0" anchor="t"/>
+          <a:lstStyle/>
+          <a:p>
+            <a:pPr algn="ctr" indent="0" marL="0">
+              <a:buNone/>
+            </a:pPr>
+            <a:r>
+              <a:rPr lang="en-US" sz="1100" dirty="0">
+                <a:solidFill>
+                  <a:srgbClr val="CBD5E1"/>
+                </a:solidFill>
+                <a:latin typeface="Calibri" pitchFamily="34" charset="0"/>
+                <a:ea typeface="Calibri" pitchFamily="34" charset="-122"/>
+                <a:cs typeface="Calibri" pitchFamily="34" charset="-120"/>
+              </a:rPr>
+              <a:t>Saved to history with its runbook and report</a:t>
+            </a:r>
+            <a:endParaRPr lang="en-US" sz="1100" dirty="0"/>
+          </a:p>
+        </p:txBody>
+      </p:sp>
+      <p:sp>
+        <p:nvSpPr>
+          <p:cNvPr id="18" name="Shape 13"/>
+          <p:cNvSpPr/>
+          <p:nvPr/>
+        </p:nvSpPr>
+        <p:spPr>
+          <a:xfrm>
+            <a:off x="5010912" y="1691640"/>
+            <a:ext cx="640080" cy="0"/>
+          </a:xfrm>
+          <a:prstGeom prst="line">
+            <a:avLst/>
+          </a:prstGeom>
+          <a:noFill/>
+          <a:ln w="19050">
+            <a:solidFill>
+              <a:srgbClr val="475569"/>
+            </a:solidFill>
+            <a:prstDash val="solid"/>
+            <a:tailEnd type="triangle"/>
+          </a:ln>
+        </p:spPr>
+      </p:sp>
+      <p:sp>
+        <p:nvSpPr>
+          <p:cNvPr id="19" name="Shape 14"/>
+          <p:cNvSpPr/>
+          <p:nvPr/>
+        </p:nvSpPr>
+        <p:spPr>
+          <a:xfrm>
+            <a:off x="5916168" y="1371600"/>
+            <a:ext cx="640080" cy="640080"/>
+          </a:xfrm>
+          <a:prstGeom prst="roundRect">
+            <a:avLst>
+              <a:gd name="adj" fmla="val 17143"/>
+            </a:avLst>
+          </a:prstGeom>
+          <a:solidFill>
+            <a:srgbClr val="14B8A6"/>
+          </a:solidFill>
+          <a:ln w="12700">
+            <a:solidFill>
+              <a:srgbClr val="14B8A6"/>
+            </a:solidFill>
+            <a:prstDash val="solid"/>
+          </a:ln>
+        </p:spPr>
+      </p:sp>
+      <p:pic>
+        <p:nvPicPr>
+          <p:cNvPr id="20" name="Image 3" descr="email icon">    </p:cNvPr>
+          <p:cNvPicPr>
+            <a:picLocks noChangeAspect="1"/>
+          </p:cNvPicPr>
+          <p:nvPr/>
+        </p:nvPicPr>
+        <p:blipFill>
+          <a:blip r:embed="rId4"/>
+          <a:stretch>
+            <a:fillRect/>
+          </a:stretch>
+        </p:blipFill>
+        <p:spPr>
+          <a:xfrm>
+            <a:off x="6082589" y="1538021"/>
+            <a:ext cx="307238" cy="307238"/>
+          </a:xfrm>
+          <a:prstGeom prst="rect">
+            <a:avLst/>
+          </a:prstGeom>
+        </p:spPr>
+      </p:pic>
+      <p:sp>
+        <p:nvSpPr>
+          <p:cNvPr id="21" name="Text 15"/>
+          <p:cNvSpPr txBox="1"/>
+          <p:nvPr/>
+        </p:nvSpPr>
+        <p:spPr>
+          <a:xfrm>
+            <a:off x="5504688" y="2103120"/>
+            <a:ext cx="1463040" cy="320040"/>
+          </a:xfrm>
+          <a:prstGeom prst="rect">
+            <a:avLst/>
+          </a:prstGeom>
+          <a:noFill/>
+          <a:ln/>
+        </p:spPr>
+        <p:txBody>
+          <a:bodyPr wrap="square" lIns="0" tIns="0" rIns="0" bIns="0" rtlCol="0" anchor="ctr"/>
+          <a:lstStyle/>
+          <a:p>
+            <a:pPr algn="ctr" indent="0" marL="0">
+              <a:buNone/>
+            </a:pPr>
+            <a:r>
+              <a:rPr lang="en-US" sz="1500" b="1" dirty="0">
+                <a:solidFill>
+                  <a:srgbClr val="FFFFFF"/>
+                </a:solidFill>
+                <a:latin typeface="Arial" pitchFamily="34" charset="0"/>
+                <a:ea typeface="Arial" pitchFamily="34" charset="-122"/>
+                <a:cs typeface="Arial" pitchFamily="34" charset="-120"/>
+              </a:rPr>
+              <a:t>Email</a:t>
+            </a:r>
+            <a:endParaRPr lang="en-US" sz="1500" dirty="0"/>
+          </a:p>
+        </p:txBody>
+      </p:sp>
+      <p:sp>
+        <p:nvSpPr>
+          <p:cNvPr id="22" name="Text 16"/>
+          <p:cNvSpPr txBox="1"/>
+          <p:nvPr/>
+        </p:nvSpPr>
+        <p:spPr>
+          <a:xfrm>
+            <a:off x="5504688" y="2450592"/>
+            <a:ext cx="1463040" cy="685800"/>
+          </a:xfrm>
+          <a:prstGeom prst="rect">
+            <a:avLst/>
+          </a:prstGeom>
+          <a:noFill/>
+          <a:ln/>
+        </p:spPr>
+        <p:txBody>
+          <a:bodyPr wrap="square" lIns="0" tIns="0" rIns="0" bIns="0" rtlCol="0" anchor="t"/>
+          <a:lstStyle/>
+          <a:p>
+            <a:pPr algn="ctr" indent="0" marL="0">
+              <a:buNone/>
+            </a:pPr>
+            <a:r>
+              <a:rPr lang="en-US" sz="1100" dirty="0">
+                <a:solidFill>
+                  <a:srgbClr val="CBD5E1"/>
+                </a:solidFill>
+                <a:latin typeface="Calibri" pitchFamily="34" charset="0"/>
+                <a:ea typeface="Calibri" pitchFamily="34" charset="-122"/>
+                <a:cs typeface="Calibri" pitchFamily="34" charset="-120"/>
+              </a:rPr>
+              <a:t>Facts-only summary to the runbook owner</a:t>
+            </a:r>
+            <a:endParaRPr lang="en-US" sz="1100" dirty="0"/>
+          </a:p>
+        </p:txBody>
+      </p:sp>
+      <p:sp>
+        <p:nvSpPr>
+          <p:cNvPr id="23" name="Shape 17"/>
+          <p:cNvSpPr/>
+          <p:nvPr/>
+        </p:nvSpPr>
+        <p:spPr>
+          <a:xfrm>
+            <a:off x="6693408" y="1691640"/>
+            <a:ext cx="640080" cy="0"/>
+          </a:xfrm>
+          <a:prstGeom prst="line">
+            <a:avLst/>
+          </a:prstGeom>
+          <a:noFill/>
+          <a:ln w="19050">
+            <a:solidFill>
+              <a:srgbClr val="475569"/>
+            </a:solidFill>
+            <a:prstDash val="solid"/>
+            <a:tailEnd type="triangle"/>
+          </a:ln>
+        </p:spPr>
+      </p:sp>
+      <p:sp>
+        <p:nvSpPr>
+          <p:cNvPr id="24" name="Shape 18"/>
+          <p:cNvSpPr/>
+          <p:nvPr/>
+        </p:nvSpPr>
+        <p:spPr>
+          <a:xfrm>
+            <a:off x="7598664" y="1371600"/>
+            <a:ext cx="640080" cy="640080"/>
+          </a:xfrm>
+          <a:prstGeom prst="roundRect">
+            <a:avLst>
+              <a:gd name="adj" fmla="val 17143"/>
+            </a:avLst>
+          </a:prstGeom>
+          <a:solidFill>
+            <a:srgbClr val="F5A524"/>
+          </a:solidFill>
+          <a:ln w="12700">
+            <a:solidFill>
+              <a:srgbClr val="F5A524"/>
+            </a:solidFill>
+            <a:prstDash val="solid"/>
+          </a:ln>
+        </p:spPr>
+      </p:sp>
+      <p:pic>
+        <p:nvPicPr>
+          <p:cNvPr id="25" name="Image 4" descr="reviewer icon">    </p:cNvPr>
+          <p:cNvPicPr>
+            <a:picLocks noChangeAspect="1"/>
+          </p:cNvPicPr>
+          <p:nvPr/>
+        </p:nvPicPr>
+        <p:blipFill>
+          <a:blip r:embed="rId5"/>
+          <a:stretch>
+            <a:fillRect/>
+          </a:stretch>
+        </p:blipFill>
+        <p:spPr>
+          <a:xfrm>
+            <a:off x="7765085" y="1538021"/>
+            <a:ext cx="307238" cy="307238"/>
+          </a:xfrm>
+          <a:prstGeom prst="rect">
+            <a:avLst/>
+          </a:prstGeom>
+        </p:spPr>
+      </p:pic>
+      <p:sp>
+        <p:nvSpPr>
+          <p:cNvPr id="26" name="Text 19"/>
+          <p:cNvSpPr txBox="1"/>
+          <p:nvPr/>
+        </p:nvSpPr>
+        <p:spPr>
+          <a:xfrm>
+            <a:off x="7187184" y="2103120"/>
+            <a:ext cx="1463040" cy="320040"/>
+          </a:xfrm>
+          <a:prstGeom prst="rect">
+            <a:avLst/>
+          </a:prstGeom>
+          <a:noFill/>
+          <a:ln/>
+        </p:spPr>
+        <p:txBody>
+          <a:bodyPr wrap="square" lIns="0" tIns="0" rIns="0" bIns="0" rtlCol="0" anchor="ctr"/>
+          <a:lstStyle/>
+          <a:p>
+            <a:pPr algn="ctr" indent="0" marL="0">
+              <a:buNone/>
+            </a:pPr>
+            <a:r>
+              <a:rPr lang="en-US" sz="1500" b="1" dirty="0">
+                <a:solidFill>
+                  <a:srgbClr val="FFFFFF"/>
+                </a:solidFill>
+                <a:latin typeface="Arial" pitchFamily="34" charset="0"/>
+                <a:ea typeface="Arial" pitchFamily="34" charset="-122"/>
+                <a:cs typeface="Arial" pitchFamily="34" charset="-120"/>
+              </a:rPr>
+              <a:t>Review</a:t>
+            </a:r>
+            <a:endParaRPr lang="en-US" sz="1500" dirty="0"/>
+          </a:p>
+        </p:txBody>
+      </p:sp>
+      <p:sp>
+        <p:nvSpPr>
+          <p:cNvPr id="27" name="Text 20"/>
+          <p:cNvSpPr txBox="1"/>
+          <p:nvPr/>
+        </p:nvSpPr>
+        <p:spPr>
+          <a:xfrm>
+            <a:off x="7187184" y="2450592"/>
+            <a:ext cx="1463040" cy="685800"/>
+          </a:xfrm>
+          <a:prstGeom prst="rect">
+            <a:avLst/>
+          </a:prstGeom>
+          <a:noFill/>
+          <a:ln/>
+        </p:spPr>
+        <p:txBody>
+          <a:bodyPr wrap="square" lIns="0" tIns="0" rIns="0" bIns="0" rtlCol="0" anchor="t"/>
+          <a:lstStyle/>
+          <a:p>
+            <a:pPr algn="ctr" indent="0" marL="0">
+              <a:buNone/>
+            </a:pPr>
+            <a:r>
+              <a:rPr lang="en-US" sz="1100" dirty="0">
+                <a:solidFill>
+                  <a:srgbClr val="CBD5E1"/>
+                </a:solidFill>
+                <a:latin typeface="Calibri" pitchFamily="34" charset="0"/>
+                <a:ea typeface="Calibri" pitchFamily="34" charset="-122"/>
+                <a:cs typeface="Calibri" pitchFamily="34" charset="-120"/>
+              </a:rPr>
+              <a:t>Open the report; a person starts any dry run</a:t>
+            </a:r>
+            <a:endParaRPr lang="en-US" sz="1100" dirty="0"/>
+          </a:p>
+        </p:txBody>
+      </p:sp>
+      <p:sp>
+        <p:nvSpPr>
+          <p:cNvPr id="28" name="Text 21"/>
+          <p:cNvSpPr txBox="1"/>
+          <p:nvPr/>
+        </p:nvSpPr>
+        <p:spPr>
+          <a:xfrm>
+            <a:off x="457200" y="3337560"/>
+            <a:ext cx="3657600" cy="274320"/>
+          </a:xfrm>
+          <a:prstGeom prst="rect">
+            <a:avLst/>
+          </a:prstGeom>
+          <a:noFill/>
+          <a:ln/>
+        </p:spPr>
+        <p:txBody>
+          <a:bodyPr wrap="square" lIns="0" tIns="0" rIns="0" bIns="0" rtlCol="0" anchor="ctr"/>
+          <a:lstStyle/>
+          <a:p>
+            <a:pPr indent="0" marL="0">
+              <a:buNone/>
+            </a:pPr>
+            <a:r>
+              <a:rPr lang="en-US" sz="1200" b="1" dirty="0">
+                <a:solidFill>
+                  <a:srgbClr val="F5A524"/>
+                </a:solidFill>
+                <a:latin typeface="Arial" pitchFamily="34" charset="0"/>
+                <a:ea typeface="Arial" pitchFamily="34" charset="-122"/>
+                <a:cs typeface="Arial" pitchFamily="34" charset="-120"/>
+              </a:rPr>
+              <a:t>Cadences</a:t>
+            </a:r>
+            <a:endParaRPr lang="en-US" sz="1200" dirty="0"/>
+          </a:p>
+        </p:txBody>
+      </p:sp>
+      <p:sp>
+        <p:nvSpPr>
+          <p:cNvPr id="29" name="Shape 22"/>
+          <p:cNvSpPr/>
+          <p:nvPr/>
+        </p:nvSpPr>
+        <p:spPr>
+          <a:xfrm>
+            <a:off x="457200" y="3675888"/>
+            <a:ext cx="1188720" cy="274320"/>
+          </a:xfrm>
+          <a:prstGeom prst="roundRect">
+            <a:avLst>
+              <a:gd name="adj" fmla="val 26667"/>
+            </a:avLst>
+          </a:prstGeom>
+          <a:solidFill>
+            <a:srgbClr val="14B8A6"/>
+          </a:solidFill>
+          <a:ln w="12700">
+            <a:solidFill>
+              <a:srgbClr val="14B8A6"/>
+            </a:solidFill>
+            <a:prstDash val="solid"/>
+          </a:ln>
+        </p:spPr>
+      </p:sp>
+      <p:sp>
+        <p:nvSpPr>
+          <p:cNvPr id="30" name="Text 23"/>
+          <p:cNvSpPr txBox="1"/>
+          <p:nvPr/>
+        </p:nvSpPr>
+        <p:spPr>
+          <a:xfrm>
+            <a:off x="457200" y="3675888"/>
+            <a:ext cx="1188720" cy="274320"/>
+          </a:xfrm>
+          <a:prstGeom prst="rect">
+            <a:avLst/>
+          </a:prstGeom>
+          <a:noFill/>
+          <a:ln/>
+        </p:spPr>
+        <p:txBody>
+          <a:bodyPr wrap="square" lIns="0" tIns="0" rIns="0" bIns="0" rtlCol="0" anchor="ctr"/>
+          <a:lstStyle/>
+          <a:p>
+            <a:pPr algn="ctr" indent="0" marL="0">
+              <a:buNone/>
+            </a:pPr>
+            <a:r>
+              <a:rPr lang="en-US" sz="1100" b="1" dirty="0">
+                <a:solidFill>
+                  <a:srgbClr val="0E1726"/>
+                </a:solidFill>
+                <a:latin typeface="Calibri" pitchFamily="34" charset="0"/>
+                <a:ea typeface="Calibri" pitchFamily="34" charset="-122"/>
+                <a:cs typeface="Calibri" pitchFamily="34" charset="-120"/>
+              </a:rPr>
+              <a:t>daily</a:t>
+            </a:r>
+            <a:endParaRPr lang="en-US" sz="1100" dirty="0"/>
+          </a:p>
+        </p:txBody>
+      </p:sp>
+      <p:sp>
+        <p:nvSpPr>
+          <p:cNvPr id="31" name="Text 24"/>
+          <p:cNvSpPr txBox="1"/>
+          <p:nvPr/>
+        </p:nvSpPr>
+        <p:spPr>
+          <a:xfrm>
+            <a:off x="1783080" y="3675888"/>
+            <a:ext cx="2560320" cy="274320"/>
+          </a:xfrm>
+          <a:prstGeom prst="rect">
+            <a:avLst/>
+          </a:prstGeom>
+          <a:noFill/>
+          <a:ln/>
+        </p:spPr>
+        <p:txBody>
+          <a:bodyPr wrap="square" lIns="0" tIns="0" rIns="0" bIns="0" rtlCol="0" anchor="ctr"/>
+          <a:lstStyle/>
+          <a:p>
+            <a:pPr indent="0" marL="0">
+              <a:buNone/>
+            </a:pPr>
+            <a:r>
+              <a:rPr lang="en-US" sz="1200" dirty="0">
+                <a:solidFill>
+                  <a:srgbClr val="CBD5E1"/>
+                </a:solidFill>
+                <a:latin typeface="Calibri" pitchFamily="34" charset="0"/>
+                <a:ea typeface="Calibri" pitchFamily="34" charset="-122"/>
+                <a:cs typeface="Calibri" pitchFamily="34" charset="-120"/>
+              </a:rPr>
+              <a:t>every day at HH:MM</a:t>
+            </a:r>
+            <a:endParaRPr lang="en-US" sz="1200" dirty="0"/>
+          </a:p>
+        </p:txBody>
+      </p:sp>
+      <p:sp>
+        <p:nvSpPr>
+          <p:cNvPr id="32" name="Shape 25"/>
+          <p:cNvSpPr/>
+          <p:nvPr/>
+        </p:nvSpPr>
+        <p:spPr>
+          <a:xfrm>
+            <a:off x="457200" y="4041648"/>
+            <a:ext cx="1188720" cy="274320"/>
+          </a:xfrm>
+          <a:prstGeom prst="roundRect">
+            <a:avLst>
+              <a:gd name="adj" fmla="val 26667"/>
+            </a:avLst>
+          </a:prstGeom>
+          <a:solidFill>
+            <a:srgbClr val="14B8A6"/>
+          </a:solidFill>
+          <a:ln w="12700">
+            <a:solidFill>
+              <a:srgbClr val="14B8A6"/>
+            </a:solidFill>
+            <a:prstDash val="solid"/>
+          </a:ln>
+        </p:spPr>
+      </p:sp>
+      <p:sp>
+        <p:nvSpPr>
+          <p:cNvPr id="33" name="Text 26"/>
+          <p:cNvSpPr txBox="1"/>
+          <p:nvPr/>
+        </p:nvSpPr>
+        <p:spPr>
+          <a:xfrm>
+            <a:off x="457200" y="4041648"/>
+            <a:ext cx="1188720" cy="274320"/>
+          </a:xfrm>
+          <a:prstGeom prst="rect">
+            <a:avLst/>
+          </a:prstGeom>
+          <a:noFill/>
+          <a:ln/>
+        </p:spPr>
+        <p:txBody>
+          <a:bodyPr wrap="square" lIns="0" tIns="0" rIns="0" bIns="0" rtlCol="0" anchor="ctr"/>
+          <a:lstStyle/>
+          <a:p>
+            <a:pPr algn="ctr" indent="0" marL="0">
+              <a:buNone/>
+            </a:pPr>
+            <a:r>
+              <a:rPr lang="en-US" sz="1100" b="1" dirty="0">
+                <a:solidFill>
+                  <a:srgbClr val="0E1726"/>
+                </a:solidFill>
+                <a:latin typeface="Calibri" pitchFamily="34" charset="0"/>
+                <a:ea typeface="Calibri" pitchFamily="34" charset="-122"/>
+                <a:cs typeface="Calibri" pitchFamily="34" charset="-120"/>
+              </a:rPr>
+              <a:t>weekly</a:t>
+            </a:r>
+            <a:endParaRPr lang="en-US" sz="1100" dirty="0"/>
+          </a:p>
+        </p:txBody>
+      </p:sp>
+      <p:sp>
+        <p:nvSpPr>
+          <p:cNvPr id="34" name="Text 27"/>
+          <p:cNvSpPr txBox="1"/>
+          <p:nvPr/>
+        </p:nvSpPr>
+        <p:spPr>
+          <a:xfrm>
+            <a:off x="1783080" y="4041648"/>
+            <a:ext cx="2560320" cy="274320"/>
+          </a:xfrm>
+          <a:prstGeom prst="rect">
+            <a:avLst/>
+          </a:prstGeom>
+          <a:noFill/>
+          <a:ln/>
+        </p:spPr>
+        <p:txBody>
+          <a:bodyPr wrap="square" lIns="0" tIns="0" rIns="0" bIns="0" rtlCol="0" anchor="ctr"/>
+          <a:lstStyle/>
+          <a:p>
+            <a:pPr indent="0" marL="0">
+              <a:buNone/>
+            </a:pPr>
+            <a:r>
+              <a:rPr lang="en-US" sz="1200" dirty="0">
+                <a:solidFill>
+                  <a:srgbClr val="CBD5E1"/>
+                </a:solidFill>
+                <a:latin typeface="Calibri" pitchFamily="34" charset="0"/>
+                <a:ea typeface="Calibri" pitchFamily="34" charset="-122"/>
+                <a:cs typeface="Calibri" pitchFamily="34" charset="-120"/>
+              </a:rPr>
+              <a:t>chosen weekdays at HH:MM</a:t>
+            </a:r>
+            <a:endParaRPr lang="en-US" sz="1200" dirty="0"/>
+          </a:p>
+        </p:txBody>
+      </p:sp>
+      <p:sp>
+        <p:nvSpPr>
+          <p:cNvPr id="35" name="Shape 28"/>
+          <p:cNvSpPr/>
+          <p:nvPr/>
+        </p:nvSpPr>
+        <p:spPr>
+          <a:xfrm>
+            <a:off x="457200" y="4407408"/>
+            <a:ext cx="1188720" cy="274320"/>
+          </a:xfrm>
+          <a:prstGeom prst="roundRect">
+            <a:avLst>
+              <a:gd name="adj" fmla="val 26667"/>
+            </a:avLst>
+          </a:prstGeom>
+          <a:solidFill>
+            <a:srgbClr val="14B8A6"/>
+          </a:solidFill>
+          <a:ln w="12700">
+            <a:solidFill>
+              <a:srgbClr val="14B8A6"/>
+            </a:solidFill>
+            <a:prstDash val="solid"/>
+          </a:ln>
+        </p:spPr>
+      </p:sp>
+      <p:sp>
+        <p:nvSpPr>
+          <p:cNvPr id="36" name="Text 29"/>
+          <p:cNvSpPr txBox="1"/>
+          <p:nvPr/>
+        </p:nvSpPr>
+        <p:spPr>
+          <a:xfrm>
+            <a:off x="457200" y="4407408"/>
+            <a:ext cx="1188720" cy="274320"/>
+          </a:xfrm>
+          <a:prstGeom prst="rect">
+            <a:avLst/>
+          </a:prstGeom>
+          <a:noFill/>
+          <a:ln/>
+        </p:spPr>
+        <p:txBody>
+          <a:bodyPr wrap="square" lIns="0" tIns="0" rIns="0" bIns="0" rtlCol="0" anchor="ctr"/>
+          <a:lstStyle/>
+          <a:p>
+            <a:pPr algn="ctr" indent="0" marL="0">
+              <a:buNone/>
+            </a:pPr>
+            <a:r>
+              <a:rPr lang="en-US" sz="1100" b="1" dirty="0">
+                <a:solidFill>
+                  <a:srgbClr val="0E1726"/>
+                </a:solidFill>
+                <a:latin typeface="Calibri" pitchFamily="34" charset="0"/>
+                <a:ea typeface="Calibri" pitchFamily="34" charset="-122"/>
+                <a:cs typeface="Calibri" pitchFamily="34" charset="-120"/>
+              </a:rPr>
+              <a:t>monthly</a:t>
+            </a:r>
+            <a:endParaRPr lang="en-US" sz="1100" dirty="0"/>
+          </a:p>
+        </p:txBody>
+      </p:sp>
+      <p:sp>
+        <p:nvSpPr>
+          <p:cNvPr id="37" name="Text 30"/>
+          <p:cNvSpPr txBox="1"/>
+          <p:nvPr/>
+        </p:nvSpPr>
+        <p:spPr>
+          <a:xfrm>
+            <a:off x="1783080" y="4407408"/>
+            <a:ext cx="2560320" cy="274320"/>
+          </a:xfrm>
+          <a:prstGeom prst="rect">
+            <a:avLst/>
+          </a:prstGeom>
+          <a:noFill/>
+          <a:ln/>
+        </p:spPr>
+        <p:txBody>
+          <a:bodyPr wrap="square" lIns="0" tIns="0" rIns="0" bIns="0" rtlCol="0" anchor="ctr"/>
+          <a:lstStyle/>
+          <a:p>
+            <a:pPr indent="0" marL="0">
+              <a:buNone/>
+            </a:pPr>
+            <a:r>
+              <a:rPr lang="en-US" sz="1200" dirty="0">
+                <a:solidFill>
+                  <a:srgbClr val="CBD5E1"/>
+                </a:solidFill>
+                <a:latin typeface="Calibri" pitchFamily="34" charset="0"/>
+                <a:ea typeface="Calibri" pitchFamily="34" charset="-122"/>
+                <a:cs typeface="Calibri" pitchFamily="34" charset="-120"/>
+              </a:rPr>
+              <a:t>day 1-31 or the last day of the month</a:t>
+            </a:r>
+            <a:endParaRPr lang="en-US" sz="1200" dirty="0"/>
+          </a:p>
+        </p:txBody>
+      </p:sp>
+      <p:sp>
+        <p:nvSpPr>
+          <p:cNvPr id="38" name="Shape 31"/>
+          <p:cNvSpPr/>
+          <p:nvPr/>
+        </p:nvSpPr>
+        <p:spPr>
+          <a:xfrm>
+            <a:off x="4754880" y="3337560"/>
+            <a:ext cx="3931920" cy="1143000"/>
+          </a:xfrm>
+          <a:prstGeom prst="roundRect">
+            <a:avLst>
+              <a:gd name="adj" fmla="val 8000"/>
+            </a:avLst>
+          </a:prstGeom>
+          <a:solidFill>
+            <a:srgbClr val="1B2A41"/>
+          </a:solidFill>
+          <a:ln w="12700">
+            <a:solidFill>
+              <a:srgbClr val="1B2A41"/>
+            </a:solidFill>
+            <a:prstDash val="solid"/>
+          </a:ln>
+        </p:spPr>
+      </p:sp>
+      <p:sp>
+        <p:nvSpPr>
+          <p:cNvPr id="39" name="Text 32"/>
+          <p:cNvSpPr txBox="1"/>
+          <p:nvPr/>
+        </p:nvSpPr>
+        <p:spPr>
+          <a:xfrm>
+            <a:off x="4937760" y="3474720"/>
+            <a:ext cx="3657600" cy="960120"/>
+          </a:xfrm>
+          <a:prstGeom prst="rect">
+            <a:avLst/>
+          </a:prstGeom>
+          <a:noFill/>
+          <a:ln/>
+        </p:spPr>
+        <p:txBody>
+          <a:bodyPr wrap="square" lIns="0" tIns="0" rIns="0" bIns="0" rtlCol="0" anchor="t"/>
+          <a:lstStyle/>
+          <a:p>
+            <a:pPr indent="0" marL="0">
+              <a:spcAft>
+                <a:spcPts val="300"/>
+              </a:spcAft>
+              <a:buNone/>
+            </a:pPr>
+            <a:r>
+              <a:rPr lang="en-US" sz="1200" b="1" dirty="0">
+                <a:solidFill>
+                  <a:srgbClr val="F5A524"/>
+                </a:solidFill>
+                <a:latin typeface="Calibri" pitchFamily="34" charset="0"/>
+                <a:ea typeface="Calibri" pitchFamily="34" charset="-122"/>
+                <a:cs typeface="Calibri" pitchFamily="34" charset="-120"/>
+              </a:rPr>
+              <a:t>Safe by design</a:t>
+            </a:r>
+            <a:endParaRPr lang="en-US" sz="1200" dirty="0"/>
+          </a:p>
+          <a:p>
+            <a:pPr marL="152400" indent="-152400">
+              <a:spcAft>
+                <a:spcPts val="300"/>
+              </a:spcAft>
+              <a:buSzPct val="100000"/>
+              <a:buChar char="•"/>
+            </a:pPr>
+            <a:r>
+              <a:rPr lang="en-US" sz="1200" dirty="0">
+                <a:solidFill>
+                  <a:srgbClr val="FFFFFF"/>
+                </a:solidFill>
+                <a:latin typeface="Calibri" pitchFamily="34" charset="0"/>
+                <a:ea typeface="Calibri" pitchFamily="34" charset="-122"/>
+                <a:cs typeface="Calibri" pitchFamily="34" charset="-120"/>
+              </a:rPr>
+              <a:t>Analyzes and emails only, never executes</a:t>
+            </a:r>
+            <a:endParaRPr lang="en-US" sz="1200" dirty="0"/>
+          </a:p>
+          <a:p>
+            <a:pPr marL="152400" indent="-152400">
+              <a:spcAft>
+                <a:spcPts val="300"/>
+              </a:spcAft>
+              <a:buSzPct val="100000"/>
+              <a:buChar char="•"/>
+            </a:pPr>
+            <a:r>
+              <a:rPr lang="en-US" sz="1200" dirty="0">
+                <a:solidFill>
+                  <a:srgbClr val="FFFFFF"/>
+                </a:solidFill>
+                <a:latin typeface="Calibri" pitchFamily="34" charset="0"/>
+                <a:ea typeface="Calibri" pitchFamily="34" charset="-122"/>
+                <a:cs typeface="Calibri" pitchFamily="34" charset="-120"/>
+              </a:rPr>
+              <a:t>Emails: code facts only, no runbook or LLM text</a:t>
+            </a:r>
+            <a:endParaRPr lang="en-US" sz="1200" dirty="0"/>
+          </a:p>
+          <a:p>
+            <a:pPr marL="152400" indent="-152400">
+              <a:spcAft>
+                <a:spcPts val="300"/>
+              </a:spcAft>
+              <a:buSzPct val="100000"/>
+              <a:buChar char="•"/>
+            </a:pPr>
+            <a:r>
+              <a:rPr lang="en-US" sz="1200" dirty="0">
+                <a:solidFill>
+                  <a:srgbClr val="FFFFFF"/>
+                </a:solidFill>
+                <a:latin typeface="Calibri" pitchFamily="34" charset="0"/>
+                <a:ea typeface="Calibri" pitchFamily="34" charset="-122"/>
+                <a:cs typeface="Calibri" pitchFamily="34" charset="-120"/>
+              </a:rPr>
+              <a:t>Pause one or all, run now; missed slots run once</a:t>
+            </a:r>
+            <a:endParaRPr lang="en-US" sz="1200" dirty="0"/>
+          </a:p>
+        </p:txBody>
+      </p:sp>
+    </p:spTree>
+  </p:cSld>
+  <p:clrMapOvr>
+    <a:masterClrMapping/>
+  </p:clrMapOvr>
+</p:sld>
+</file>
+
 <file path=ppt/slides/slide2.xml><?xml version="1.0" encoding="utf-8"?>
 <p:sld xmlns:a="http://schemas.openxmlformats.org/drawingml/2006/main" xmlns:r="http://schemas.openxmlformats.org/officeDocument/2006/relationships" xmlns:p="http://schemas.openxmlformats.org/presentationml/2006/main">
   <p:cSld name="Slide 2">
@@ -3296,7 +4634,7 @@
                 <a:ea typeface="Calibri" pitchFamily="34" charset="-122"/>
                 <a:cs typeface="Calibri" pitchFamily="34" charset="-120"/>
               </a:rPr>
-              <a:t>Same service layer behind the CLI, REST API and React dashboard</a:t>
+              <a:t>Same service layer behind the CLI, REST API, React dashboard and scheduler</a:t>
             </a:r>
             <a:endParaRPr lang="en-US" sz="1100" dirty="0"/>
           </a:p>
@@ -7420,7 +8758,7 @@
                 <a:ea typeface="Calibri" pitchFamily="34" charset="-122"/>
                 <a:cs typeface="Calibri" pitchFamily="34" charset="-120"/>
               </a:rPr>
-              <a:t>dr-agent analyze | execute | history</a:t>
+              <a:t>dr-agent analyze | execute | history | schedule</a:t>
             </a:r>
             <a:endParaRPr lang="en-US" sz="1000" dirty="0"/>
           </a:p>
@@ -7894,7 +9232,7 @@
                 <a:ea typeface="Calibri" pitchFamily="34" charset="-122"/>
                 <a:cs typeface="Calibri" pitchFamily="34" charset="-120"/>
               </a:rPr>
-              <a:t>Docker Compose + GitHub Actions CI</a:t>
+              <a:t>Docker Compose + Mailpit + GitHub Actions CI</a:t>
             </a:r>
             <a:endParaRPr lang="en-US" sz="1200" dirty="0"/>
           </a:p>
@@ -7933,7 +9271,7 @@
                 <a:ea typeface="Arial" pitchFamily="34" charset="-122"/>
                 <a:cs typeface="Arial" pitchFamily="34" charset="-120"/>
               </a:rPr>
-              <a:t>98.9%</a:t>
+              <a:t>99%</a:t>
             </a:r>
             <a:endParaRPr lang="en-US" sz="3200" dirty="0"/>
           </a:p>
@@ -8011,7 +9349,7 @@
                 <a:ea typeface="Arial" pitchFamily="34" charset="-122"/>
                 <a:cs typeface="Arial" pitchFamily="34" charset="-120"/>
               </a:rPr>
-              <a:t>94</a:t>
+              <a:t>149</a:t>
             </a:r>
             <a:endParaRPr lang="en-US" sz="3200" dirty="0"/>
           </a:p>
@@ -8511,7 +9849,7 @@
                 <a:ea typeface="Calibri" pitchFamily="34" charset="-122"/>
                 <a:cs typeface="Calibri" pitchFamily="34" charset="-120"/>
               </a:rPr>
-              <a:t>Check readiness on every runbook change, in seconds, instead of a once-a-year DR exercise.</a:t>
+              <a:t>Check readiness on every change or on a daily, weekly or monthly schedule, not once a year.</a:t>
             </a:r>
             <a:endParaRPr lang="en-US" sz="1100" dirty="0"/>
           </a:p>

</xml_diff>

<commit_message>
Add a future enhancements slide to the project deck
- New slide 11 "What's next": live integrations, identity and access,
  on-call and tickets, org-wide readiness
- Each plugs in behind an existing protocol, so the core stays unchanged

Co-Authored-By: Claude Opus 5.5 <noreply@anthropic.com>
</commit_message>
<xml_diff>
--- a/docs/DR_Readiness_Agent.pptx
+++ b/docs/DR_Readiness_Agent.pptx
@@ -15,6 +15,7 @@
     <p:sldId id="262" r:id="rId8"/>
     <p:sldId id="264" r:id="rId15"/>
     <p:sldId id="263" r:id="rId9"/>
+    <p:sldId id="266" r:id="rId17"/>
   </p:sldIdLst>
   <p:notesMasterIdLst>
     <p:notesMasterId r:id="rId10"/>
@@ -804,6 +805,94 @@
             <a:r>
               <a:rPr lang="en-US" dirty="0"/>
               <a:t>DR runbooks are written by hand, rarely validated and never cross-checked against live systems. The DR Readiness Agent turns that once-a-year exercise into a repeatable check, and can then carry out the recovery with human approval. Created by Jotiba Patil.</a:t>
+            </a:r>
+            <a:endParaRPr lang="en-US" dirty="0"/>
+          </a:p>
+        </p:txBody>
+      </p:sp>
+      <p:sp>
+        <p:nvSpPr>
+          <p:cNvPr id="4" name="Slide Number Placeholder 3"/>
+          <p:cNvSpPr>
+            <a:spLocks noGrp="1"/>
+          </p:cNvSpPr>
+          <p:nvPr>
+            <p:ph type="sldNum" sz="quarter" idx="10"/>
+          </p:nvPr>
+        </p:nvSpPr>
+        <p:spPr/>
+        <p:txBody>
+          <a:bodyPr/>
+          <a:lstStyle/>
+          <a:p>
+            <a:fld id="{F7021451-1387-4CA6-816F-3879F97B5CBC}" type="slidenum">
+              <a:rPr lang="en-US"/>
+              <a:t>1</a:t>
+            </a:fld>
+            <a:endParaRPr lang="en-US"/>
+          </a:p>
+        </p:txBody>
+      </p:sp>
+    </p:spTree>
+    <p:extLst>
+      <p:ext uri="{BB962C8B-B14F-4D97-AF65-F5344CB8AC3E}">
+        <p14:creationId xmlns:p14="http://schemas.microsoft.com/office/powerpoint/2010/main" val="1024086991"/>
+      </p:ext>
+    </p:extLst>
+  </p:cSld>
+  <p:clrMapOvr>
+    <a:masterClrMapping/>
+  </p:clrMapOvr>
+</p:notes>
+</file>
+
+<file path=ppt/notesSlides/notesSlide11.xml><?xml version="1.0" encoding="utf-8"?>
+<p:notes xmlns:a="http://schemas.openxmlformats.org/drawingml/2006/main" xmlns:r="http://schemas.openxmlformats.org/officeDocument/2006/relationships" xmlns:p="http://schemas.openxmlformats.org/presentationml/2006/main">
+  <p:cSld>
+    <p:spTree>
+      <p:nvGrpSpPr>
+        <p:cNvPr id="1" name=""/>
+        <p:cNvGrpSpPr/>
+        <p:nvPr/>
+      </p:nvGrpSpPr>
+      <p:grpSpPr>
+        <a:xfrm>
+          <a:off x="0" y="0"/>
+          <a:ext cx="0" cy="0"/>
+          <a:chOff x="0" y="0"/>
+          <a:chExt cx="0" cy="0"/>
+        </a:xfrm>
+      </p:grpSpPr>
+      <p:sp>
+        <p:nvSpPr>
+          <p:cNvPr id="2" name="Slide Image Placeholder 1"/>
+          <p:cNvSpPr>
+            <a:spLocks noGrp="1" noRot="1" noChangeAspect="1"/>
+          </p:cNvSpPr>
+          <p:nvPr>
+            <p:ph type="sldImg"/>
+          </p:nvPr>
+        </p:nvSpPr>
+        <p:spPr/>
+      </p:sp>
+      <p:sp>
+        <p:nvSpPr>
+          <p:cNvPr id="3" name="Notes Placeholder 2"/>
+          <p:cNvSpPr>
+            <a:spLocks noGrp="1"/>
+          </p:cNvSpPr>
+          <p:nvPr>
+            <p:ph type="body" idx="1"/>
+          </p:nvPr>
+        </p:nvSpPr>
+        <p:spPr/>
+        <p:txBody>
+          <a:bodyPr/>
+          <a:lstStyle/>
+          <a:p>
+            <a:r>
+              <a:rPr lang="en-US" dirty="0"/>
+              <a:t>Four enhancements take the agent from a proof of concept to production. Live integrations replace the mocked health inventory and mock MCP server with real checks and real tool servers, each with its own threat review. Identity and access closes the PoC gaps: SSO login, verified approvers instead of self-declared names, role-based permissions and rate limiting. On-call and ticketing sends findings to the right person: owners come from the CMDB or directory, alerts go through PagerDuty, Slack or Teams, and gaps become tickets. Org-wide readiness looks across services: a shared dependency map, a readiness check on every runbook pull request, and Postgres so several API instances can run. None of these needs a core rewrite: each is a new implementation behind a protocol the code already injects.</a:t>
             </a:r>
             <a:endParaRPr lang="en-US" dirty="0"/>
           </a:p>
@@ -3644,6 +3733,1367 @@
 </p:sld>
 </file>
 
+<file path=ppt/slides/slide11.xml><?xml version="1.0" encoding="utf-8"?>
+<p:sld xmlns:a="http://schemas.openxmlformats.org/drawingml/2006/main" xmlns:r="http://schemas.openxmlformats.org/officeDocument/2006/relationships" xmlns:p="http://schemas.openxmlformats.org/presentationml/2006/main">
+  <p:cSld name="Slide 11">
+    <p:bg>
+      <p:bgPr>
+        <a:solidFill>
+          <a:srgbClr val="0E1726"/>
+        </a:solidFill>
+      </p:bgPr>
+    </p:bg>
+    <p:spTree>
+      <p:nvGrpSpPr>
+        <p:cNvPr id="1" name=""/>
+        <p:cNvGrpSpPr/>
+        <p:nvPr/>
+      </p:nvGrpSpPr>
+      <p:grpSpPr>
+        <a:xfrm>
+          <a:off x="0" y="0"/>
+          <a:ext cx="0" cy="0"/>
+          <a:chOff x="0" y="0"/>
+          <a:chExt cx="0" cy="0"/>
+        </a:xfrm>
+      </p:grpSpPr>
+      <p:sp>
+        <p:nvSpPr>
+          <p:cNvPr id="2" name="Text 0"/>
+          <p:cNvSpPr txBox="1"/>
+          <p:nvPr/>
+        </p:nvSpPr>
+        <p:spPr>
+          <a:xfrm>
+            <a:off x="457200" y="274320"/>
+            <a:ext cx="8229600" cy="274320"/>
+          </a:xfrm>
+          <a:prstGeom prst="rect">
+            <a:avLst/>
+          </a:prstGeom>
+          <a:noFill/>
+          <a:ln/>
+        </p:spPr>
+        <p:txBody>
+          <a:bodyPr wrap="square" lIns="0" tIns="0" rIns="0" bIns="0" rtlCol="0" anchor="ctr"/>
+          <a:lstStyle/>
+          <a:p>
+            <a:pPr indent="0" marL="0">
+              <a:buNone/>
+            </a:pPr>
+            <a:r>
+              <a:rPr lang="en-US" sz="1100" b="1" spc="300" kern="0" dirty="0">
+                <a:solidFill>
+                  <a:srgbClr val="F5A524"/>
+                </a:solidFill>
+                <a:latin typeface="Arial" pitchFamily="34" charset="0"/>
+                <a:ea typeface="Arial" pitchFamily="34" charset="-122"/>
+                <a:cs typeface="Arial" pitchFamily="34" charset="-120"/>
+              </a:rPr>
+              <a:t>WHAT'S NEXT</a:t>
+            </a:r>
+            <a:endParaRPr lang="en-US" sz="1100" dirty="0"/>
+          </a:p>
+        </p:txBody>
+      </p:sp>
+      <p:sp>
+        <p:nvSpPr>
+          <p:cNvPr id="3" name="Text 1"/>
+          <p:cNvSpPr txBox="1"/>
+          <p:nvPr/>
+        </p:nvSpPr>
+        <p:spPr>
+          <a:xfrm>
+            <a:off x="457200" y="530352"/>
+            <a:ext cx="8229600" cy="548640"/>
+          </a:xfrm>
+          <a:prstGeom prst="rect">
+            <a:avLst/>
+          </a:prstGeom>
+          <a:noFill/>
+          <a:ln/>
+        </p:spPr>
+        <p:txBody>
+          <a:bodyPr wrap="square" lIns="0" tIns="0" rIns="0" bIns="0" rtlCol="0" anchor="ctr"/>
+          <a:lstStyle/>
+          <a:p>
+            <a:pPr indent="0" marL="0">
+              <a:buNone/>
+            </a:pPr>
+            <a:r>
+              <a:rPr lang="en-US" sz="2800" b="1" dirty="0">
+                <a:solidFill>
+                  <a:srgbClr val="FFFFFF"/>
+                </a:solidFill>
+                <a:latin typeface="Arial" pitchFamily="34" charset="0"/>
+                <a:ea typeface="Arial" pitchFamily="34" charset="-122"/>
+                <a:cs typeface="Arial" pitchFamily="34" charset="-120"/>
+              </a:rPr>
+              <a:t>From proof of concept to production</a:t>
+            </a:r>
+            <a:endParaRPr lang="en-US" sz="2800" dirty="0"/>
+          </a:p>
+        </p:txBody>
+      </p:sp>
+      <p:sp>
+        <p:nvSpPr>
+          <p:cNvPr id="4" name="Card 01"/>
+          <p:cNvSpPr/>
+          <p:nvPr/>
+        </p:nvSpPr>
+        <p:spPr>
+          <a:xfrm>
+            <a:off x="457200" y="1280160"/>
+            <a:ext cx="1954530" cy="2743200"/>
+          </a:xfrm>
+          <a:prstGeom prst="roundRect">
+            <a:avLst>
+              <a:gd name="adj" fmla="val 3743"/>
+            </a:avLst>
+          </a:prstGeom>
+          <a:solidFill>
+            <a:srgbClr val="1B2A41"/>
+          </a:solidFill>
+          <a:ln w="12700">
+            <a:solidFill>
+              <a:srgbClr val="1B2A41"/>
+            </a:solidFill>
+            <a:prstDash val="solid"/>
+          </a:ln>
+        </p:spPr>
+      </p:sp>
+      <p:sp>
+        <p:nvSpPr>
+          <p:cNvPr id="5" name="Icon tile 01"/>
+          <p:cNvSpPr/>
+          <p:nvPr/>
+        </p:nvSpPr>
+        <p:spPr>
+          <a:xfrm>
+            <a:off x="621792" y="1444752"/>
+            <a:ext cx="457200" cy="457200"/>
+          </a:xfrm>
+          <a:prstGeom prst="roundRect">
+            <a:avLst>
+              <a:gd name="adj" fmla="val 24000"/>
+            </a:avLst>
+          </a:prstGeom>
+          <a:solidFill>
+            <a:srgbClr val="14B8A6"/>
+          </a:solidFill>
+          <a:ln w="12700">
+            <a:solidFill>
+              <a:srgbClr val="14B8A6"/>
+            </a:solidFill>
+            <a:prstDash val="solid"/>
+          </a:ln>
+        </p:spPr>
+      </p:sp>
+      <p:pic>
+        <p:nvPicPr>
+          <p:cNvPr id="6" name="Icon 01" descr="Live integrations">    </p:cNvPr>
+          <p:cNvPicPr>
+            <a:picLocks noChangeAspect="1"/>
+          </p:cNvPicPr>
+          <p:nvPr/>
+        </p:nvPicPr>
+        <p:blipFill>
+          <a:blip r:embed="rId1"/>
+          <a:stretch>
+            <a:fillRect/>
+          </a:stretch>
+        </p:blipFill>
+        <p:spPr>
+          <a:xfrm>
+            <a:off x="731520" y="1554480"/>
+            <a:ext cx="237744" cy="237744"/>
+          </a:xfrm>
+          <a:prstGeom prst="rect">
+            <a:avLst/>
+          </a:prstGeom>
+        </p:spPr>
+      </p:pic>
+      <p:sp>
+        <p:nvSpPr>
+          <p:cNvPr id="7" name="Text 4"/>
+          <p:cNvSpPr txBox="1"/>
+          <p:nvPr/>
+        </p:nvSpPr>
+        <p:spPr>
+          <a:xfrm>
+            <a:off x="1698498" y="1444752"/>
+            <a:ext cx="548640" cy="457200"/>
+          </a:xfrm>
+          <a:prstGeom prst="rect">
+            <a:avLst/>
+          </a:prstGeom>
+          <a:noFill/>
+          <a:ln/>
+        </p:spPr>
+        <p:txBody>
+          <a:bodyPr wrap="square" lIns="0" tIns="0" rIns="0" bIns="0" rtlCol="0" anchor="t"/>
+          <a:lstStyle/>
+          <a:p>
+            <a:pPr algn="r" indent="0" marL="0">
+              <a:buNone/>
+            </a:pPr>
+            <a:r>
+              <a:rPr lang="en-US" sz="1800" b="1" dirty="0">
+                <a:solidFill>
+                  <a:srgbClr val="64748B"/>
+                </a:solidFill>
+                <a:latin typeface="Arial" pitchFamily="34" charset="0"/>
+                <a:ea typeface="Arial" pitchFamily="34" charset="-122"/>
+                <a:cs typeface="Arial" pitchFamily="34" charset="-120"/>
+              </a:rPr>
+              <a:t>01</a:t>
+            </a:r>
+            <a:endParaRPr lang="en-US" sz="1800" dirty="0"/>
+          </a:p>
+        </p:txBody>
+      </p:sp>
+      <p:sp>
+        <p:nvSpPr>
+          <p:cNvPr id="8" name="Text 5"/>
+          <p:cNvSpPr txBox="1"/>
+          <p:nvPr/>
+        </p:nvSpPr>
+        <p:spPr>
+          <a:xfrm>
+            <a:off x="621792" y="2029968"/>
+            <a:ext cx="1625346" cy="292608"/>
+          </a:xfrm>
+          <a:prstGeom prst="rect">
+            <a:avLst/>
+          </a:prstGeom>
+          <a:noFill/>
+          <a:ln/>
+        </p:spPr>
+        <p:txBody>
+          <a:bodyPr wrap="square" lIns="0" tIns="0" rIns="0" bIns="0" rtlCol="0" anchor="ctr"/>
+          <a:lstStyle/>
+          <a:p>
+            <a:pPr indent="0" marL="0">
+              <a:buNone/>
+            </a:pPr>
+            <a:r>
+              <a:rPr lang="en-US" sz="1300" b="1" dirty="0">
+                <a:solidFill>
+                  <a:srgbClr val="FFFFFF"/>
+                </a:solidFill>
+                <a:latin typeface="Arial" pitchFamily="34" charset="0"/>
+                <a:ea typeface="Arial" pitchFamily="34" charset="-122"/>
+                <a:cs typeface="Arial" pitchFamily="34" charset="-120"/>
+              </a:rPr>
+              <a:t>Live integrations</a:t>
+            </a:r>
+            <a:endParaRPr lang="en-US" sz="1300" dirty="0"/>
+          </a:p>
+        </p:txBody>
+      </p:sp>
+      <p:sp>
+        <p:nvSpPr>
+          <p:cNvPr id="9" name="Text 6"/>
+          <p:cNvSpPr txBox="1"/>
+          <p:nvPr/>
+        </p:nvSpPr>
+        <p:spPr>
+          <a:xfrm>
+            <a:off x="621792" y="2395728"/>
+            <a:ext cx="1625346" cy="1188720"/>
+          </a:xfrm>
+          <a:prstGeom prst="rect">
+            <a:avLst/>
+          </a:prstGeom>
+          <a:noFill/>
+          <a:ln/>
+        </p:spPr>
+        <p:txBody>
+          <a:bodyPr wrap="square" lIns="0" tIns="0" rIns="0" bIns="0" rtlCol="0" anchor="t"/>
+          <a:lstStyle/>
+          <a:p>
+            <a:pPr marL="127000" indent="-127000">
+              <a:spcAft>
+                <a:spcPts val="400"/>
+              </a:spcAft>
+              <a:buSzPct val="100000"/>
+              <a:buChar char="•"/>
+            </a:pPr>
+            <a:r>
+              <a:rPr lang="en-US" sz="1050" dirty="0">
+                <a:solidFill>
+                  <a:srgbClr val="CBD5E1"/>
+                </a:solidFill>
+                <a:latin typeface="Calibri" pitchFamily="34" charset="0"/>
+                <a:ea typeface="Calibri" pitchFamily="34" charset="-122"/>
+                <a:cs typeface="Calibri" pitchFamily="34" charset="-120"/>
+              </a:rPr>
+              <a:t>Live health checks: Prometheus, Kubernetes</a:t>
+            </a:r>
+            <a:endParaRPr lang="en-US" sz="1050" dirty="0"/>
+          </a:p>
+          <a:p>
+            <a:pPr marL="127000" indent="-127000">
+              <a:spcAft>
+                <a:spcPts val="400"/>
+              </a:spcAft>
+              <a:buSzPct val="100000"/>
+              <a:buChar char="•"/>
+            </a:pPr>
+            <a:r>
+              <a:rPr lang="en-US" sz="1050" dirty="0">
+                <a:solidFill>
+                  <a:srgbClr val="CBD5E1"/>
+                </a:solidFill>
+                <a:latin typeface="Calibri" pitchFamily="34" charset="0"/>
+                <a:ea typeface="Calibri" pitchFamily="34" charset="-122"/>
+                <a:cs typeface="Calibri" pitchFamily="34" charset="-120"/>
+              </a:rPr>
+              <a:t>Real MCP servers: Kubernetes, PostgreSQL</a:t>
+            </a:r>
+            <a:endParaRPr lang="en-US" sz="1050" dirty="0"/>
+          </a:p>
+          <a:p>
+            <a:pPr marL="127000" indent="-127000">
+              <a:spcAft>
+                <a:spcPts val="400"/>
+              </a:spcAft>
+              <a:buSzPct val="100000"/>
+              <a:buChar char="•"/>
+            </a:pPr>
+            <a:r>
+              <a:rPr lang="en-US" sz="1050" dirty="0">
+                <a:solidFill>
+                  <a:srgbClr val="CBD5E1"/>
+                </a:solidFill>
+                <a:latin typeface="Calibri" pitchFamily="34" charset="0"/>
+                <a:ea typeface="Calibri" pitchFamily="34" charset="-122"/>
+                <a:cs typeface="Calibri" pitchFamily="34" charset="-120"/>
+              </a:rPr>
+              <a:t>Runbooks from Git or Confluence</a:t>
+            </a:r>
+            <a:endParaRPr lang="en-US" sz="1050" dirty="0"/>
+          </a:p>
+        </p:txBody>
+      </p:sp>
+      <p:sp>
+        <p:nvSpPr>
+          <p:cNvPr id="10" name="Text 7"/>
+          <p:cNvSpPr txBox="1"/>
+          <p:nvPr/>
+        </p:nvSpPr>
+        <p:spPr>
+          <a:xfrm>
+            <a:off x="621792" y="3639312"/>
+            <a:ext cx="1625346" cy="237744"/>
+          </a:xfrm>
+          <a:prstGeom prst="rect">
+            <a:avLst/>
+          </a:prstGeom>
+          <a:noFill/>
+          <a:ln/>
+        </p:spPr>
+        <p:txBody>
+          <a:bodyPr wrap="square" lIns="0" tIns="0" rIns="0" bIns="0" rtlCol="0" anchor="ctr"/>
+          <a:lstStyle/>
+          <a:p>
+            <a:pPr indent="0" marL="0">
+              <a:buNone/>
+            </a:pPr>
+            <a:r>
+              <a:rPr lang="en-US" sz="1000" i="1" dirty="0">
+                <a:solidFill>
+                  <a:srgbClr val="14B8A6"/>
+                </a:solidFill>
+                <a:latin typeface="Calibri" pitchFamily="34" charset="0"/>
+                <a:ea typeface="Calibri" pitchFamily="34" charset="-122"/>
+                <a:cs typeface="Calibri" pitchFamily="34" charset="-120"/>
+              </a:rPr>
+              <a:t>Replaces the mocks</a:t>
+            </a:r>
+            <a:endParaRPr lang="en-US" sz="1000" dirty="0"/>
+          </a:p>
+        </p:txBody>
+      </p:sp>
+      <p:sp>
+        <p:nvSpPr>
+          <p:cNvPr id="11" name="Card 02"/>
+          <p:cNvSpPr/>
+          <p:nvPr/>
+        </p:nvSpPr>
+        <p:spPr>
+          <a:xfrm>
+            <a:off x="2548890" y="1280160"/>
+            <a:ext cx="1954530" cy="2743200"/>
+          </a:xfrm>
+          <a:prstGeom prst="roundRect">
+            <a:avLst>
+              <a:gd name="adj" fmla="val 3743"/>
+            </a:avLst>
+          </a:prstGeom>
+          <a:solidFill>
+            <a:srgbClr val="1B2A41"/>
+          </a:solidFill>
+          <a:ln w="12700">
+            <a:solidFill>
+              <a:srgbClr val="1B2A41"/>
+            </a:solidFill>
+            <a:prstDash val="solid"/>
+          </a:ln>
+        </p:spPr>
+      </p:sp>
+      <p:sp>
+        <p:nvSpPr>
+          <p:cNvPr id="12" name="Icon tile 02"/>
+          <p:cNvSpPr/>
+          <p:nvPr/>
+        </p:nvSpPr>
+        <p:spPr>
+          <a:xfrm>
+            <a:off x="2713482" y="1444752"/>
+            <a:ext cx="457200" cy="457200"/>
+          </a:xfrm>
+          <a:prstGeom prst="roundRect">
+            <a:avLst>
+              <a:gd name="adj" fmla="val 24000"/>
+            </a:avLst>
+          </a:prstGeom>
+          <a:solidFill>
+            <a:srgbClr val="E5484D"/>
+          </a:solidFill>
+          <a:ln w="12700">
+            <a:solidFill>
+              <a:srgbClr val="E5484D"/>
+            </a:solidFill>
+            <a:prstDash val="solid"/>
+          </a:ln>
+        </p:spPr>
+      </p:sp>
+      <p:pic>
+        <p:nvPicPr>
+          <p:cNvPr id="13" name="Icon 02" descr="Identity and access">    </p:cNvPr>
+          <p:cNvPicPr>
+            <a:picLocks noChangeAspect="1"/>
+          </p:cNvPicPr>
+          <p:nvPr/>
+        </p:nvPicPr>
+        <p:blipFill>
+          <a:blip r:embed="rId2"/>
+          <a:stretch>
+            <a:fillRect/>
+          </a:stretch>
+        </p:blipFill>
+        <p:spPr>
+          <a:xfrm>
+            <a:off x="2823210" y="1554480"/>
+            <a:ext cx="237744" cy="237744"/>
+          </a:xfrm>
+          <a:prstGeom prst="rect">
+            <a:avLst/>
+          </a:prstGeom>
+        </p:spPr>
+      </p:pic>
+      <p:sp>
+        <p:nvSpPr>
+          <p:cNvPr id="14" name="Text 10"/>
+          <p:cNvSpPr txBox="1"/>
+          <p:nvPr/>
+        </p:nvSpPr>
+        <p:spPr>
+          <a:xfrm>
+            <a:off x="3790188" y="1444752"/>
+            <a:ext cx="548640" cy="457200"/>
+          </a:xfrm>
+          <a:prstGeom prst="rect">
+            <a:avLst/>
+          </a:prstGeom>
+          <a:noFill/>
+          <a:ln/>
+        </p:spPr>
+        <p:txBody>
+          <a:bodyPr wrap="square" lIns="0" tIns="0" rIns="0" bIns="0" rtlCol="0" anchor="t"/>
+          <a:lstStyle/>
+          <a:p>
+            <a:pPr algn="r" indent="0" marL="0">
+              <a:buNone/>
+            </a:pPr>
+            <a:r>
+              <a:rPr lang="en-US" sz="1800" b="1" dirty="0">
+                <a:solidFill>
+                  <a:srgbClr val="64748B"/>
+                </a:solidFill>
+                <a:latin typeface="Arial" pitchFamily="34" charset="0"/>
+                <a:ea typeface="Arial" pitchFamily="34" charset="-122"/>
+                <a:cs typeface="Arial" pitchFamily="34" charset="-120"/>
+              </a:rPr>
+              <a:t>02</a:t>
+            </a:r>
+            <a:endParaRPr lang="en-US" sz="1800" dirty="0"/>
+          </a:p>
+        </p:txBody>
+      </p:sp>
+      <p:sp>
+        <p:nvSpPr>
+          <p:cNvPr id="15" name="Text 11"/>
+          <p:cNvSpPr txBox="1"/>
+          <p:nvPr/>
+        </p:nvSpPr>
+        <p:spPr>
+          <a:xfrm>
+            <a:off x="2713482" y="2029968"/>
+            <a:ext cx="1625346" cy="292608"/>
+          </a:xfrm>
+          <a:prstGeom prst="rect">
+            <a:avLst/>
+          </a:prstGeom>
+          <a:noFill/>
+          <a:ln/>
+        </p:spPr>
+        <p:txBody>
+          <a:bodyPr wrap="square" lIns="0" tIns="0" rIns="0" bIns="0" rtlCol="0" anchor="ctr"/>
+          <a:lstStyle/>
+          <a:p>
+            <a:pPr indent="0" marL="0">
+              <a:buNone/>
+            </a:pPr>
+            <a:r>
+              <a:rPr lang="en-US" sz="1300" b="1" dirty="0">
+                <a:solidFill>
+                  <a:srgbClr val="FFFFFF"/>
+                </a:solidFill>
+                <a:latin typeface="Arial" pitchFamily="34" charset="0"/>
+                <a:ea typeface="Arial" pitchFamily="34" charset="-122"/>
+                <a:cs typeface="Arial" pitchFamily="34" charset="-120"/>
+              </a:rPr>
+              <a:t>Identity and access</a:t>
+            </a:r>
+            <a:endParaRPr lang="en-US" sz="1300" dirty="0"/>
+          </a:p>
+        </p:txBody>
+      </p:sp>
+      <p:sp>
+        <p:nvSpPr>
+          <p:cNvPr id="16" name="Text 12"/>
+          <p:cNvSpPr txBox="1"/>
+          <p:nvPr/>
+        </p:nvSpPr>
+        <p:spPr>
+          <a:xfrm>
+            <a:off x="2713482" y="2395728"/>
+            <a:ext cx="1625346" cy="1188720"/>
+          </a:xfrm>
+          <a:prstGeom prst="rect">
+            <a:avLst/>
+          </a:prstGeom>
+          <a:noFill/>
+          <a:ln/>
+        </p:spPr>
+        <p:txBody>
+          <a:bodyPr wrap="square" lIns="0" tIns="0" rIns="0" bIns="0" rtlCol="0" anchor="t"/>
+          <a:lstStyle/>
+          <a:p>
+            <a:pPr marL="127000" indent="-127000">
+              <a:spcAft>
+                <a:spcPts val="400"/>
+              </a:spcAft>
+              <a:buSzPct val="100000"/>
+              <a:buChar char="•"/>
+            </a:pPr>
+            <a:r>
+              <a:rPr lang="en-US" sz="1050" dirty="0">
+                <a:solidFill>
+                  <a:srgbClr val="CBD5E1"/>
+                </a:solidFill>
+                <a:latin typeface="Calibri" pitchFamily="34" charset="0"/>
+                <a:ea typeface="Calibri" pitchFamily="34" charset="-122"/>
+                <a:cs typeface="Calibri" pitchFamily="34" charset="-120"/>
+              </a:rPr>
+              <a:t>SSO login (OIDC) for every user</a:t>
+            </a:r>
+            <a:endParaRPr lang="en-US" sz="1050" dirty="0"/>
+          </a:p>
+          <a:p>
+            <a:pPr marL="127000" indent="-127000">
+              <a:spcAft>
+                <a:spcPts val="400"/>
+              </a:spcAft>
+              <a:buSzPct val="100000"/>
+              <a:buChar char="•"/>
+            </a:pPr>
+            <a:r>
+              <a:rPr lang="en-US" sz="1050" dirty="0">
+                <a:solidFill>
+                  <a:srgbClr val="CBD5E1"/>
+                </a:solidFill>
+                <a:latin typeface="Calibri" pitchFamily="34" charset="0"/>
+                <a:ea typeface="Calibri" pitchFamily="34" charset="-122"/>
+                <a:cs typeface="Calibri" pitchFamily="34" charset="-120"/>
+              </a:rPr>
+              <a:t>Verified approvers and role-based permissions</a:t>
+            </a:r>
+            <a:endParaRPr lang="en-US" sz="1050" dirty="0"/>
+          </a:p>
+          <a:p>
+            <a:pPr marL="127000" indent="-127000">
+              <a:spcAft>
+                <a:spcPts val="400"/>
+              </a:spcAft>
+              <a:buSzPct val="100000"/>
+              <a:buChar char="•"/>
+            </a:pPr>
+            <a:r>
+              <a:rPr lang="en-US" sz="1050" dirty="0">
+                <a:solidFill>
+                  <a:srgbClr val="CBD5E1"/>
+                </a:solidFill>
+                <a:latin typeface="Calibri" pitchFamily="34" charset="0"/>
+                <a:ea typeface="Calibri" pitchFamily="34" charset="-122"/>
+                <a:cs typeface="Calibri" pitchFamily="34" charset="-120"/>
+              </a:rPr>
+              <a:t>Rate limits and per-user access to history</a:t>
+            </a:r>
+            <a:endParaRPr lang="en-US" sz="1050" dirty="0"/>
+          </a:p>
+        </p:txBody>
+      </p:sp>
+      <p:sp>
+        <p:nvSpPr>
+          <p:cNvPr id="17" name="Text 13"/>
+          <p:cNvSpPr txBox="1"/>
+          <p:nvPr/>
+        </p:nvSpPr>
+        <p:spPr>
+          <a:xfrm>
+            <a:off x="2713482" y="3639312"/>
+            <a:ext cx="1625346" cy="237744"/>
+          </a:xfrm>
+          <a:prstGeom prst="rect">
+            <a:avLst/>
+          </a:prstGeom>
+          <a:noFill/>
+          <a:ln/>
+        </p:spPr>
+        <p:txBody>
+          <a:bodyPr wrap="square" lIns="0" tIns="0" rIns="0" bIns="0" rtlCol="0" anchor="ctr"/>
+          <a:lstStyle/>
+          <a:p>
+            <a:pPr indent="0" marL="0">
+              <a:buNone/>
+            </a:pPr>
+            <a:r>
+              <a:rPr lang="en-US" sz="1000" i="1" dirty="0">
+                <a:solidFill>
+                  <a:srgbClr val="E5484D"/>
+                </a:solidFill>
+                <a:latin typeface="Calibri" pitchFamily="34" charset="0"/>
+                <a:ea typeface="Calibri" pitchFamily="34" charset="-122"/>
+                <a:cs typeface="Calibri" pitchFamily="34" charset="-120"/>
+              </a:rPr>
+              <a:t>Closes the PoC security gaps</a:t>
+            </a:r>
+            <a:endParaRPr lang="en-US" sz="1000" dirty="0"/>
+          </a:p>
+        </p:txBody>
+      </p:sp>
+      <p:sp>
+        <p:nvSpPr>
+          <p:cNvPr id="18" name="Card 03"/>
+          <p:cNvSpPr/>
+          <p:nvPr/>
+        </p:nvSpPr>
+        <p:spPr>
+          <a:xfrm>
+            <a:off x="4640580" y="1280160"/>
+            <a:ext cx="1954530" cy="2743200"/>
+          </a:xfrm>
+          <a:prstGeom prst="roundRect">
+            <a:avLst>
+              <a:gd name="adj" fmla="val 3743"/>
+            </a:avLst>
+          </a:prstGeom>
+          <a:solidFill>
+            <a:srgbClr val="1B2A41"/>
+          </a:solidFill>
+          <a:ln w="12700">
+            <a:solidFill>
+              <a:srgbClr val="1B2A41"/>
+            </a:solidFill>
+            <a:prstDash val="solid"/>
+          </a:ln>
+        </p:spPr>
+      </p:sp>
+      <p:sp>
+        <p:nvSpPr>
+          <p:cNvPr id="19" name="Icon tile 03"/>
+          <p:cNvSpPr/>
+          <p:nvPr/>
+        </p:nvSpPr>
+        <p:spPr>
+          <a:xfrm>
+            <a:off x="4805172" y="1444752"/>
+            <a:ext cx="457200" cy="457200"/>
+          </a:xfrm>
+          <a:prstGeom prst="roundRect">
+            <a:avLst>
+              <a:gd name="adj" fmla="val 24000"/>
+            </a:avLst>
+          </a:prstGeom>
+          <a:solidFill>
+            <a:srgbClr val="F5A524"/>
+          </a:solidFill>
+          <a:ln w="12700">
+            <a:solidFill>
+              <a:srgbClr val="F5A524"/>
+            </a:solidFill>
+            <a:prstDash val="solid"/>
+          </a:ln>
+        </p:spPr>
+      </p:sp>
+      <p:pic>
+        <p:nvPicPr>
+          <p:cNvPr id="20" name="Icon 03" descr="On-call and tickets">    </p:cNvPr>
+          <p:cNvPicPr>
+            <a:picLocks noChangeAspect="1"/>
+          </p:cNvPicPr>
+          <p:nvPr/>
+        </p:nvPicPr>
+        <p:blipFill>
+          <a:blip r:embed="rId3"/>
+          <a:stretch>
+            <a:fillRect/>
+          </a:stretch>
+        </p:blipFill>
+        <p:spPr>
+          <a:xfrm>
+            <a:off x="4914900" y="1554480"/>
+            <a:ext cx="237744" cy="237744"/>
+          </a:xfrm>
+          <a:prstGeom prst="rect">
+            <a:avLst/>
+          </a:prstGeom>
+        </p:spPr>
+      </p:pic>
+      <p:sp>
+        <p:nvSpPr>
+          <p:cNvPr id="21" name="Text 16"/>
+          <p:cNvSpPr txBox="1"/>
+          <p:nvPr/>
+        </p:nvSpPr>
+        <p:spPr>
+          <a:xfrm>
+            <a:off x="5881878" y="1444752"/>
+            <a:ext cx="548640" cy="457200"/>
+          </a:xfrm>
+          <a:prstGeom prst="rect">
+            <a:avLst/>
+          </a:prstGeom>
+          <a:noFill/>
+          <a:ln/>
+        </p:spPr>
+        <p:txBody>
+          <a:bodyPr wrap="square" lIns="0" tIns="0" rIns="0" bIns="0" rtlCol="0" anchor="t"/>
+          <a:lstStyle/>
+          <a:p>
+            <a:pPr algn="r" indent="0" marL="0">
+              <a:buNone/>
+            </a:pPr>
+            <a:r>
+              <a:rPr lang="en-US" sz="1800" b="1" dirty="0">
+                <a:solidFill>
+                  <a:srgbClr val="64748B"/>
+                </a:solidFill>
+                <a:latin typeface="Arial" pitchFamily="34" charset="0"/>
+                <a:ea typeface="Arial" pitchFamily="34" charset="-122"/>
+                <a:cs typeface="Arial" pitchFamily="34" charset="-120"/>
+              </a:rPr>
+              <a:t>03</a:t>
+            </a:r>
+            <a:endParaRPr lang="en-US" sz="1800" dirty="0"/>
+          </a:p>
+        </p:txBody>
+      </p:sp>
+      <p:sp>
+        <p:nvSpPr>
+          <p:cNvPr id="22" name="Text 17"/>
+          <p:cNvSpPr txBox="1"/>
+          <p:nvPr/>
+        </p:nvSpPr>
+        <p:spPr>
+          <a:xfrm>
+            <a:off x="4805172" y="2029968"/>
+            <a:ext cx="1625346" cy="292608"/>
+          </a:xfrm>
+          <a:prstGeom prst="rect">
+            <a:avLst/>
+          </a:prstGeom>
+          <a:noFill/>
+          <a:ln/>
+        </p:spPr>
+        <p:txBody>
+          <a:bodyPr wrap="square" lIns="0" tIns="0" rIns="0" bIns="0" rtlCol="0" anchor="ctr"/>
+          <a:lstStyle/>
+          <a:p>
+            <a:pPr indent="0" marL="0">
+              <a:buNone/>
+            </a:pPr>
+            <a:r>
+              <a:rPr lang="en-US" sz="1300" b="1" dirty="0">
+                <a:solidFill>
+                  <a:srgbClr val="FFFFFF"/>
+                </a:solidFill>
+                <a:latin typeface="Arial" pitchFamily="34" charset="0"/>
+                <a:ea typeface="Arial" pitchFamily="34" charset="-122"/>
+                <a:cs typeface="Arial" pitchFamily="34" charset="-120"/>
+              </a:rPr>
+              <a:t>On-call and tickets</a:t>
+            </a:r>
+            <a:endParaRPr lang="en-US" sz="1300" dirty="0"/>
+          </a:p>
+        </p:txBody>
+      </p:sp>
+      <p:sp>
+        <p:nvSpPr>
+          <p:cNvPr id="23" name="Text 18"/>
+          <p:cNvSpPr txBox="1"/>
+          <p:nvPr/>
+        </p:nvSpPr>
+        <p:spPr>
+          <a:xfrm>
+            <a:off x="4805172" y="2395728"/>
+            <a:ext cx="1625346" cy="1188720"/>
+          </a:xfrm>
+          <a:prstGeom prst="rect">
+            <a:avLst/>
+          </a:prstGeom>
+          <a:noFill/>
+          <a:ln/>
+        </p:spPr>
+        <p:txBody>
+          <a:bodyPr wrap="square" lIns="0" tIns="0" rIns="0" bIns="0" rtlCol="0" anchor="t"/>
+          <a:lstStyle/>
+          <a:p>
+            <a:pPr marL="127000" indent="-127000">
+              <a:spcAft>
+                <a:spcPts val="400"/>
+              </a:spcAft>
+              <a:buSzPct val="100000"/>
+              <a:buChar char="•"/>
+            </a:pPr>
+            <a:r>
+              <a:rPr lang="en-US" sz="1050" dirty="0">
+                <a:solidFill>
+                  <a:srgbClr val="CBD5E1"/>
+                </a:solidFill>
+                <a:latin typeface="Calibri" pitchFamily="34" charset="0"/>
+                <a:ea typeface="Calibri" pitchFamily="34" charset="-122"/>
+                <a:cs typeface="Calibri" pitchFamily="34" charset="-120"/>
+              </a:rPr>
+              <a:t>Owners from ServiceNow CMDB, LDAP or Okta</a:t>
+            </a:r>
+            <a:endParaRPr lang="en-US" sz="1050" dirty="0"/>
+          </a:p>
+          <a:p>
+            <a:pPr marL="127000" indent="-127000">
+              <a:spcAft>
+                <a:spcPts val="400"/>
+              </a:spcAft>
+              <a:buSzPct val="100000"/>
+              <a:buChar char="•"/>
+            </a:pPr>
+            <a:r>
+              <a:rPr lang="en-US" sz="1050" dirty="0">
+                <a:solidFill>
+                  <a:srgbClr val="CBD5E1"/>
+                </a:solidFill>
+                <a:latin typeface="Calibri" pitchFamily="34" charset="0"/>
+                <a:ea typeface="Calibri" pitchFamily="34" charset="-122"/>
+                <a:cs typeface="Calibri" pitchFamily="34" charset="-120"/>
+              </a:rPr>
+              <a:t>Alerts through PagerDuty, Slack or Teams</a:t>
+            </a:r>
+            <a:endParaRPr lang="en-US" sz="1050" dirty="0"/>
+          </a:p>
+          <a:p>
+            <a:pPr marL="127000" indent="-127000">
+              <a:spcAft>
+                <a:spcPts val="400"/>
+              </a:spcAft>
+              <a:buSzPct val="100000"/>
+              <a:buChar char="•"/>
+            </a:pPr>
+            <a:r>
+              <a:rPr lang="en-US" sz="1050" dirty="0">
+                <a:solidFill>
+                  <a:srgbClr val="CBD5E1"/>
+                </a:solidFill>
+                <a:latin typeface="Calibri" pitchFamily="34" charset="0"/>
+                <a:ea typeface="Calibri" pitchFamily="34" charset="-122"/>
+                <a:cs typeface="Calibri" pitchFamily="34" charset="-120"/>
+              </a:rPr>
+              <a:t>Each gap becomes a ticket with an owner</a:t>
+            </a:r>
+            <a:endParaRPr lang="en-US" sz="1050" dirty="0"/>
+          </a:p>
+        </p:txBody>
+      </p:sp>
+      <p:sp>
+        <p:nvSpPr>
+          <p:cNvPr id="24" name="Text 19"/>
+          <p:cNvSpPr txBox="1"/>
+          <p:nvPr/>
+        </p:nvSpPr>
+        <p:spPr>
+          <a:xfrm>
+            <a:off x="4805172" y="3639312"/>
+            <a:ext cx="1625346" cy="237744"/>
+          </a:xfrm>
+          <a:prstGeom prst="rect">
+            <a:avLst/>
+          </a:prstGeom>
+          <a:noFill/>
+          <a:ln/>
+        </p:spPr>
+        <p:txBody>
+          <a:bodyPr wrap="square" lIns="0" tIns="0" rIns="0" bIns="0" rtlCol="0" anchor="ctr"/>
+          <a:lstStyle/>
+          <a:p>
+            <a:pPr indent="0" marL="0">
+              <a:buNone/>
+            </a:pPr>
+            <a:r>
+              <a:rPr lang="en-US" sz="1000" i="1" dirty="0">
+                <a:solidFill>
+                  <a:srgbClr val="F5A524"/>
+                </a:solidFill>
+                <a:latin typeface="Calibri" pitchFamily="34" charset="0"/>
+                <a:ea typeface="Calibri" pitchFamily="34" charset="-122"/>
+                <a:cs typeface="Calibri" pitchFamily="34" charset="-120"/>
+              </a:rPr>
+              <a:t>Findings reach the right person</a:t>
+            </a:r>
+            <a:endParaRPr lang="en-US" sz="1000" dirty="0"/>
+          </a:p>
+        </p:txBody>
+      </p:sp>
+      <p:sp>
+        <p:nvSpPr>
+          <p:cNvPr id="25" name="Card 04"/>
+          <p:cNvSpPr/>
+          <p:nvPr/>
+        </p:nvSpPr>
+        <p:spPr>
+          <a:xfrm>
+            <a:off x="6732270" y="1280160"/>
+            <a:ext cx="1954530" cy="2743200"/>
+          </a:xfrm>
+          <a:prstGeom prst="roundRect">
+            <a:avLst>
+              <a:gd name="adj" fmla="val 3743"/>
+            </a:avLst>
+          </a:prstGeom>
+          <a:solidFill>
+            <a:srgbClr val="1B2A41"/>
+          </a:solidFill>
+          <a:ln w="12700">
+            <a:solidFill>
+              <a:srgbClr val="1B2A41"/>
+            </a:solidFill>
+            <a:prstDash val="solid"/>
+          </a:ln>
+        </p:spPr>
+      </p:sp>
+      <p:sp>
+        <p:nvSpPr>
+          <p:cNvPr id="26" name="Icon tile 04"/>
+          <p:cNvSpPr/>
+          <p:nvPr/>
+        </p:nvSpPr>
+        <p:spPr>
+          <a:xfrm>
+            <a:off x="6896862" y="1444752"/>
+            <a:ext cx="457200" cy="457200"/>
+          </a:xfrm>
+          <a:prstGeom prst="roundRect">
+            <a:avLst>
+              <a:gd name="adj" fmla="val 24000"/>
+            </a:avLst>
+          </a:prstGeom>
+          <a:solidFill>
+            <a:srgbClr val="334155"/>
+          </a:solidFill>
+          <a:ln w="12700">
+            <a:solidFill>
+              <a:srgbClr val="334155"/>
+            </a:solidFill>
+            <a:prstDash val="solid"/>
+          </a:ln>
+        </p:spPr>
+      </p:sp>
+      <p:pic>
+        <p:nvPicPr>
+          <p:cNvPr id="27" name="Icon 04" descr="Org-wide readiness">    </p:cNvPr>
+          <p:cNvPicPr>
+            <a:picLocks noChangeAspect="1"/>
+          </p:cNvPicPr>
+          <p:nvPr/>
+        </p:nvPicPr>
+        <p:blipFill>
+          <a:blip r:embed="rId4"/>
+          <a:stretch>
+            <a:fillRect/>
+          </a:stretch>
+        </p:blipFill>
+        <p:spPr>
+          <a:xfrm>
+            <a:off x="7006590" y="1554480"/>
+            <a:ext cx="237744" cy="237744"/>
+          </a:xfrm>
+          <a:prstGeom prst="rect">
+            <a:avLst/>
+          </a:prstGeom>
+        </p:spPr>
+      </p:pic>
+      <p:sp>
+        <p:nvSpPr>
+          <p:cNvPr id="28" name="Text 22"/>
+          <p:cNvSpPr txBox="1"/>
+          <p:nvPr/>
+        </p:nvSpPr>
+        <p:spPr>
+          <a:xfrm>
+            <a:off x="7973568" y="1444752"/>
+            <a:ext cx="548640" cy="457200"/>
+          </a:xfrm>
+          <a:prstGeom prst="rect">
+            <a:avLst/>
+          </a:prstGeom>
+          <a:noFill/>
+          <a:ln/>
+        </p:spPr>
+        <p:txBody>
+          <a:bodyPr wrap="square" lIns="0" tIns="0" rIns="0" bIns="0" rtlCol="0" anchor="t"/>
+          <a:lstStyle/>
+          <a:p>
+            <a:pPr algn="r" indent="0" marL="0">
+              <a:buNone/>
+            </a:pPr>
+            <a:r>
+              <a:rPr lang="en-US" sz="1800" b="1" dirty="0">
+                <a:solidFill>
+                  <a:srgbClr val="64748B"/>
+                </a:solidFill>
+                <a:latin typeface="Arial" pitchFamily="34" charset="0"/>
+                <a:ea typeface="Arial" pitchFamily="34" charset="-122"/>
+                <a:cs typeface="Arial" pitchFamily="34" charset="-120"/>
+              </a:rPr>
+              <a:t>04</a:t>
+            </a:r>
+            <a:endParaRPr lang="en-US" sz="1800" dirty="0"/>
+          </a:p>
+        </p:txBody>
+      </p:sp>
+      <p:sp>
+        <p:nvSpPr>
+          <p:cNvPr id="29" name="Text 23"/>
+          <p:cNvSpPr txBox="1"/>
+          <p:nvPr/>
+        </p:nvSpPr>
+        <p:spPr>
+          <a:xfrm>
+            <a:off x="6896862" y="2029968"/>
+            <a:ext cx="1625346" cy="292608"/>
+          </a:xfrm>
+          <a:prstGeom prst="rect">
+            <a:avLst/>
+          </a:prstGeom>
+          <a:noFill/>
+          <a:ln/>
+        </p:spPr>
+        <p:txBody>
+          <a:bodyPr wrap="square" lIns="0" tIns="0" rIns="0" bIns="0" rtlCol="0" anchor="ctr"/>
+          <a:lstStyle/>
+          <a:p>
+            <a:pPr indent="0" marL="0">
+              <a:buNone/>
+            </a:pPr>
+            <a:r>
+              <a:rPr lang="en-US" sz="1300" b="1" dirty="0">
+                <a:solidFill>
+                  <a:srgbClr val="FFFFFF"/>
+                </a:solidFill>
+                <a:latin typeface="Arial" pitchFamily="34" charset="0"/>
+                <a:ea typeface="Arial" pitchFamily="34" charset="-122"/>
+                <a:cs typeface="Arial" pitchFamily="34" charset="-120"/>
+              </a:rPr>
+              <a:t>Org-wide readiness</a:t>
+            </a:r>
+            <a:endParaRPr lang="en-US" sz="1300" dirty="0"/>
+          </a:p>
+        </p:txBody>
+      </p:sp>
+      <p:sp>
+        <p:nvSpPr>
+          <p:cNvPr id="30" name="Text 24"/>
+          <p:cNvSpPr txBox="1"/>
+          <p:nvPr/>
+        </p:nvSpPr>
+        <p:spPr>
+          <a:xfrm>
+            <a:off x="6896862" y="2395728"/>
+            <a:ext cx="1625346" cy="1188720"/>
+          </a:xfrm>
+          <a:prstGeom prst="rect">
+            <a:avLst/>
+          </a:prstGeom>
+          <a:noFill/>
+          <a:ln/>
+        </p:spPr>
+        <p:txBody>
+          <a:bodyPr wrap="square" lIns="0" tIns="0" rIns="0" bIns="0" rtlCol="0" anchor="t"/>
+          <a:lstStyle/>
+          <a:p>
+            <a:pPr marL="127000" indent="-127000">
+              <a:spcAft>
+                <a:spcPts val="400"/>
+              </a:spcAft>
+              <a:buSzPct val="100000"/>
+              <a:buChar char="•"/>
+            </a:pPr>
+            <a:r>
+              <a:rPr lang="en-US" sz="1050" dirty="0">
+                <a:solidFill>
+                  <a:srgbClr val="CBD5E1"/>
+                </a:solidFill>
+                <a:latin typeface="Calibri" pitchFamily="34" charset="0"/>
+                <a:ea typeface="Calibri" pitchFamily="34" charset="-122"/>
+                <a:cs typeface="Calibri" pitchFamily="34" charset="-120"/>
+              </a:rPr>
+              <a:t>Dependency map across services, shared SPOFs</a:t>
+            </a:r>
+            <a:endParaRPr lang="en-US" sz="1050" dirty="0"/>
+          </a:p>
+          <a:p>
+            <a:pPr marL="127000" indent="-127000">
+              <a:spcAft>
+                <a:spcPts val="400"/>
+              </a:spcAft>
+              <a:buSzPct val="100000"/>
+              <a:buChar char="•"/>
+            </a:pPr>
+            <a:r>
+              <a:rPr lang="en-US" sz="1050" dirty="0">
+                <a:solidFill>
+                  <a:srgbClr val="CBD5E1"/>
+                </a:solidFill>
+                <a:latin typeface="Calibri" pitchFamily="34" charset="0"/>
+                <a:ea typeface="Calibri" pitchFamily="34" charset="-122"/>
+                <a:cs typeface="Calibri" pitchFamily="34" charset="-120"/>
+              </a:rPr>
+              <a:t>Readiness check on every runbook pull request</a:t>
+            </a:r>
+            <a:endParaRPr lang="en-US" sz="1050" dirty="0"/>
+          </a:p>
+          <a:p>
+            <a:pPr marL="127000" indent="-127000">
+              <a:spcAft>
+                <a:spcPts val="400"/>
+              </a:spcAft>
+              <a:buSzPct val="100000"/>
+              <a:buChar char="•"/>
+            </a:pPr>
+            <a:r>
+              <a:rPr lang="en-US" sz="1050" dirty="0">
+                <a:solidFill>
+                  <a:srgbClr val="CBD5E1"/>
+                </a:solidFill>
+                <a:latin typeface="Calibri" pitchFamily="34" charset="0"/>
+                <a:ea typeface="Calibri" pitchFamily="34" charset="-122"/>
+                <a:cs typeface="Calibri" pitchFamily="34" charset="-120"/>
+              </a:rPr>
+              <a:t>Postgres to run several API instances</a:t>
+            </a:r>
+            <a:endParaRPr lang="en-US" sz="1050" dirty="0"/>
+          </a:p>
+        </p:txBody>
+      </p:sp>
+      <p:sp>
+        <p:nvSpPr>
+          <p:cNvPr id="31" name="Text 25"/>
+          <p:cNvSpPr txBox="1"/>
+          <p:nvPr/>
+        </p:nvSpPr>
+        <p:spPr>
+          <a:xfrm>
+            <a:off x="6896862" y="3639312"/>
+            <a:ext cx="1625346" cy="237744"/>
+          </a:xfrm>
+          <a:prstGeom prst="rect">
+            <a:avLst/>
+          </a:prstGeom>
+          <a:noFill/>
+          <a:ln/>
+        </p:spPr>
+        <p:txBody>
+          <a:bodyPr wrap="square" lIns="0" tIns="0" rIns="0" bIns="0" rtlCol="0" anchor="ctr"/>
+          <a:lstStyle/>
+          <a:p>
+            <a:pPr indent="0" marL="0">
+              <a:buNone/>
+            </a:pPr>
+            <a:r>
+              <a:rPr lang="en-US" sz="1000" i="1" dirty="0">
+                <a:solidFill>
+                  <a:srgbClr val="94A3B8"/>
+                </a:solidFill>
+                <a:latin typeface="Calibri" pitchFamily="34" charset="0"/>
+                <a:ea typeface="Calibri" pitchFamily="34" charset="-122"/>
+                <a:cs typeface="Calibri" pitchFamily="34" charset="-120"/>
+              </a:rPr>
+              <a:t>Every service, one view</a:t>
+            </a:r>
+            <a:endParaRPr lang="en-US" sz="1000" dirty="0"/>
+          </a:p>
+        </p:txBody>
+      </p:sp>
+      <p:sp>
+        <p:nvSpPr>
+          <p:cNvPr id="32" name="Footer band"/>
+          <p:cNvSpPr/>
+          <p:nvPr/>
+        </p:nvSpPr>
+        <p:spPr>
+          <a:xfrm>
+            <a:off x="457200" y="4206240"/>
+            <a:ext cx="8229600" cy="502920"/>
+          </a:xfrm>
+          <a:prstGeom prst="roundRect">
+            <a:avLst>
+              <a:gd name="adj" fmla="val 14545"/>
+            </a:avLst>
+          </a:prstGeom>
+          <a:solidFill>
+            <a:srgbClr val="1B2A41"/>
+          </a:solidFill>
+          <a:ln w="12700">
+            <a:solidFill>
+              <a:srgbClr val="1B2A41"/>
+            </a:solidFill>
+            <a:prstDash val="solid"/>
+          </a:ln>
+        </p:spPr>
+      </p:sp>
+      <p:sp>
+        <p:nvSpPr>
+          <p:cNvPr id="33" name="Footer icon tile"/>
+          <p:cNvSpPr/>
+          <p:nvPr/>
+        </p:nvSpPr>
+        <p:spPr>
+          <a:xfrm>
+            <a:off x="594360" y="4297680"/>
+            <a:ext cx="320040" cy="320040"/>
+          </a:xfrm>
+          <a:prstGeom prst="roundRect">
+            <a:avLst>
+              <a:gd name="adj" fmla="val 22857"/>
+            </a:avLst>
+          </a:prstGeom>
+          <a:solidFill>
+            <a:srgbClr val="334155"/>
+          </a:solidFill>
+          <a:ln w="12700">
+            <a:solidFill>
+              <a:srgbClr val="334155"/>
+            </a:solidFill>
+            <a:prstDash val="solid"/>
+          </a:ln>
+        </p:spPr>
+      </p:sp>
+      <p:pic>
+        <p:nvPicPr>
+          <p:cNvPr id="34" name="Image 4" descr="Plugs in">    </p:cNvPr>
+          <p:cNvPicPr>
+            <a:picLocks noChangeAspect="1"/>
+          </p:cNvPicPr>
+          <p:nvPr/>
+        </p:nvPicPr>
+        <p:blipFill>
+          <a:blip r:embed="rId5"/>
+          <a:stretch>
+            <a:fillRect/>
+          </a:stretch>
+        </p:blipFill>
+        <p:spPr>
+          <a:xfrm>
+            <a:off x="672084" y="4375404"/>
+            <a:ext cx="164592" cy="164592"/>
+          </a:xfrm>
+          <a:prstGeom prst="rect">
+            <a:avLst/>
+          </a:prstGeom>
+        </p:spPr>
+      </p:pic>
+      <p:sp>
+        <p:nvSpPr>
+          <p:cNvPr id="35" name="Text 28"/>
+          <p:cNvSpPr txBox="1"/>
+          <p:nvPr/>
+        </p:nvSpPr>
+        <p:spPr>
+          <a:xfrm>
+            <a:off x="1024128" y="4206240"/>
+            <a:ext cx="7543800" cy="502920"/>
+          </a:xfrm>
+          <a:prstGeom prst="rect">
+            <a:avLst/>
+          </a:prstGeom>
+          <a:noFill/>
+          <a:ln/>
+        </p:spPr>
+        <p:txBody>
+          <a:bodyPr wrap="square" lIns="0" tIns="0" rIns="0" bIns="0" rtlCol="0" anchor="ctr"/>
+          <a:lstStyle/>
+          <a:p>
+            <a:pPr indent="0" marL="0">
+              <a:buNone/>
+            </a:pPr>
+            <a:r>
+              <a:rPr lang="en-US" sz="1100" b="1" dirty="0">
+                <a:solidFill>
+                  <a:srgbClr val="F5A524"/>
+                </a:solidFill>
+                <a:latin typeface="Arial" pitchFamily="34" charset="0"/>
+                <a:ea typeface="Arial" pitchFamily="34" charset="-122"/>
+                <a:cs typeface="Arial" pitchFamily="34" charset="-120"/>
+              </a:rPr>
+              <a:t>Plugs in  </a:t>
+            </a:r>
+            <a:pPr indent="0" marL="0">
+              <a:buNone/>
+            </a:pPr>
+            <a:r>
+              <a:rPr lang="en-US" sz="1100" dirty="0">
+                <a:solidFill>
+                  <a:srgbClr val="FFFFFF"/>
+                </a:solidFill>
+                <a:latin typeface="Calibri" pitchFamily="34" charset="0"/>
+                <a:ea typeface="Calibri" pitchFamily="34" charset="-122"/>
+                <a:cs typeface="Calibri" pitchFamily="34" charset="-120"/>
+              </a:rPr>
+              <a:t>Each is a new implementation behind an existing protocol (HealthChecker, ToolExecutor, Notifier, ContactDirectory, stores). The core stays unchanged.</a:t>
+            </a:r>
+            <a:endParaRPr lang="en-US" sz="1100" dirty="0"/>
+          </a:p>
+        </p:txBody>
+      </p:sp>
+    </p:spTree>
+  </p:cSld>
+  <p:clrMapOvr>
+    <a:masterClrMapping/>
+  </p:clrMapOvr>
+</p:sld>
+</file>
+
 <file path=ppt/slides/slide2.xml><?xml version="1.0" encoding="utf-8"?>
 <p:sld xmlns:a="http://schemas.openxmlformats.org/drawingml/2006/main" xmlns:r="http://schemas.openxmlformats.org/officeDocument/2006/relationships" xmlns:p="http://schemas.openxmlformats.org/presentationml/2006/main">
   <p:cSld name="Slide 2">

</xml_diff>